<commit_message>
Voeg economische grafieken toe aan presentaties 3.2.1, 3.2.2, 3.2.3
8 SVG-grafieken toegevoegd via Sharp PNG-pipeline:
- 3.2.1: V/A-evenwicht, MO prijsnemer vs prijszetter (side-by-side), arbeidsmarkt verschuiving (13→16 dia's)
- 3.2.2: kostencurves+winstrechthoek, CS/PS surplusdriehoeken, lange-termijn nulwinst (11→14 dia's)
- 3.2.3: monopolie MO=MK met p* op vraaglijn, winstrechthoek+CS-driehoek (9→11 dia's)

Elke grafiek op eigen dia voor rustige opbouw. Build-scripts opgeslagen voor hergebruik.
econ-pptx-templates skill uitgebreid: grafieken zijn nu standaard bij elke presentatie.

Co-Authored-By: Claude Opus 4.6 (1M context) <noreply@anthropic.com>
</commit_message>
<xml_diff>
--- a/3.2 Hoofdstuk 2 - Marktvormen en hun marktevenwicht/3.2.3 Paragraaf 3 - Monopolie/2. Leren/3.2.3 Monopolie – presentatie.pptx
+++ b/3.2 Hoofdstuk 2 - Marktvormen en hun marktevenwicht/3.2.3 Paragraaf 3 - Monopolie/2. Leren/3.2.3 Monopolie – presentatie.pptx
@@ -14,9 +14,11 @@
     <p:sldId id="262" r:id="rId8"/>
     <p:sldId id="263" r:id="rId9"/>
     <p:sldId id="264" r:id="rId10"/>
+    <p:sldId id="265" r:id="rId11"/>
+    <p:sldId id="266" r:id="rId12"/>
   </p:sldIdLst>
   <p:notesMasterIdLst>
-    <p:notesMasterId r:id="rId11"/>
+    <p:notesMasterId r:id="rId13"/>
   </p:notesMasterIdLst>
   <p:sldSz cx="9144000" cy="5143500"/>
   <p:notesSz cx="5143500" cy="9144000"/>
@@ -552,6 +554,182 @@
 </p:notes>
 </file>
 
+<file path=ppt/notesSlides/notesSlide10.xml><?xml version="1.0" encoding="utf-8"?>
+<p:notes xmlns:a="http://schemas.openxmlformats.org/drawingml/2006/main" xmlns:r="http://schemas.openxmlformats.org/officeDocument/2006/relationships" xmlns:p="http://schemas.openxmlformats.org/presentationml/2006/main">
+  <p:cSld>
+    <p:spTree>
+      <p:nvGrpSpPr>
+        <p:cNvPr id="1" name=""/>
+        <p:cNvGrpSpPr/>
+        <p:nvPr/>
+      </p:nvGrpSpPr>
+      <p:grpSpPr>
+        <a:xfrm>
+          <a:off x="0" y="0"/>
+          <a:ext cx="0" cy="0"/>
+          <a:chOff x="0" y="0"/>
+          <a:chExt cx="0" cy="0"/>
+        </a:xfrm>
+      </p:grpSpPr>
+      <p:sp>
+        <p:nvSpPr>
+          <p:cNvPr id="2" name="Slide Image Placeholder 1"/>
+          <p:cNvSpPr>
+            <a:spLocks noGrp="1" noRot="1" noChangeAspect="1"/>
+          </p:cNvSpPr>
+          <p:nvPr>
+            <p:ph type="sldImg"/>
+          </p:nvPr>
+        </p:nvSpPr>
+        <p:spPr/>
+      </p:sp>
+      <p:sp>
+        <p:nvSpPr>
+          <p:cNvPr id="3" name="Notes Placeholder 2"/>
+          <p:cNvSpPr>
+            <a:spLocks noGrp="1"/>
+          </p:cNvSpPr>
+          <p:nvPr>
+            <p:ph type="body" idx="1"/>
+          </p:nvPr>
+        </p:nvSpPr>
+        <p:spPr/>
+        <p:txBody>
+          <a:bodyPr/>
+          <a:lstStyle/>
+          <a:p>
+            <a:r>
+              <a:rPr lang="en-US" dirty="0"/>
+              <a:t>De logica: door een lagere prijs te vragen aan groepen met een lagere betalingsbereidheid, krijg je extra klanten. Zolang de prijs boven de marginale kosten ligt, is elke extra verkoop winstgevend.</a:t>
+            </a:r>
+            <a:endParaRPr lang="en-US" dirty="0"/>
+          </a:p>
+        </p:txBody>
+      </p:sp>
+      <p:sp>
+        <p:nvSpPr>
+          <p:cNvPr id="4" name="Slide Number Placeholder 3"/>
+          <p:cNvSpPr>
+            <a:spLocks noGrp="1"/>
+          </p:cNvSpPr>
+          <p:nvPr>
+            <p:ph type="sldNum" sz="quarter" idx="10"/>
+          </p:nvPr>
+        </p:nvSpPr>
+        <p:spPr/>
+        <p:txBody>
+          <a:bodyPr/>
+          <a:lstStyle/>
+          <a:p>
+            <a:fld id="{F7021451-1387-4CA6-816F-3879F97B5CBC}" type="slidenum">
+              <a:rPr lang="en-US"/>
+              <a:t>10</a:t>
+            </a:fld>
+            <a:endParaRPr lang="en-US"/>
+          </a:p>
+        </p:txBody>
+      </p:sp>
+    </p:spTree>
+    <p:extLst>
+      <p:ext uri="{BB962C8B-B14F-4D97-AF65-F5344CB8AC3E}">
+        <p14:creationId xmlns:p14="http://schemas.microsoft.com/office/powerpoint/2010/main" val="1024086991"/>
+      </p:ext>
+    </p:extLst>
+  </p:cSld>
+  <p:clrMapOvr>
+    <a:masterClrMapping/>
+  </p:clrMapOvr>
+</p:notes>
+</file>
+
+<file path=ppt/notesSlides/notesSlide11.xml><?xml version="1.0" encoding="utf-8"?>
+<p:notes xmlns:a="http://schemas.openxmlformats.org/drawingml/2006/main" xmlns:r="http://schemas.openxmlformats.org/officeDocument/2006/relationships" xmlns:p="http://schemas.openxmlformats.org/presentationml/2006/main">
+  <p:cSld>
+    <p:spTree>
+      <p:nvGrpSpPr>
+        <p:cNvPr id="1" name=""/>
+        <p:cNvGrpSpPr/>
+        <p:nvPr/>
+      </p:nvGrpSpPr>
+      <p:grpSpPr>
+        <a:xfrm>
+          <a:off x="0" y="0"/>
+          <a:ext cx="0" cy="0"/>
+          <a:chOff x="0" y="0"/>
+          <a:chExt cx="0" cy="0"/>
+        </a:xfrm>
+      </p:grpSpPr>
+      <p:sp>
+        <p:nvSpPr>
+          <p:cNvPr id="2" name="Slide Image Placeholder 1"/>
+          <p:cNvSpPr>
+            <a:spLocks noGrp="1" noRot="1" noChangeAspect="1"/>
+          </p:cNvSpPr>
+          <p:nvPr>
+            <p:ph type="sldImg"/>
+          </p:nvPr>
+        </p:nvSpPr>
+        <p:spPr/>
+      </p:sp>
+      <p:sp>
+        <p:nvSpPr>
+          <p:cNvPr id="3" name="Notes Placeholder 2"/>
+          <p:cNvSpPr>
+            <a:spLocks noGrp="1"/>
+          </p:cNvSpPr>
+          <p:nvPr>
+            <p:ph type="body" idx="1"/>
+          </p:nvPr>
+        </p:nvSpPr>
+        <p:spPr/>
+        <p:txBody>
+          <a:bodyPr/>
+          <a:lstStyle/>
+          <a:p>
+            <a:r>
+              <a:rPr lang="en-US" dirty="0"/>
+              <a:t>Vijf kernpunten. Controleer of leerlingen de prijs op de vraaglijn aflezen, de MO-formule kennen, en begrijpen waarom prijsdiscriminatie winstgevend is.</a:t>
+            </a:r>
+            <a:endParaRPr lang="en-US" dirty="0"/>
+          </a:p>
+        </p:txBody>
+      </p:sp>
+      <p:sp>
+        <p:nvSpPr>
+          <p:cNvPr id="4" name="Slide Number Placeholder 3"/>
+          <p:cNvSpPr>
+            <a:spLocks noGrp="1"/>
+          </p:cNvSpPr>
+          <p:nvPr>
+            <p:ph type="sldNum" sz="quarter" idx="10"/>
+          </p:nvPr>
+        </p:nvSpPr>
+        <p:spPr/>
+        <p:txBody>
+          <a:bodyPr/>
+          <a:lstStyle/>
+          <a:p>
+            <a:fld id="{F7021451-1387-4CA6-816F-3879F97B5CBC}" type="slidenum">
+              <a:rPr lang="en-US"/>
+              <a:t>11</a:t>
+            </a:fld>
+            <a:endParaRPr lang="en-US"/>
+          </a:p>
+        </p:txBody>
+      </p:sp>
+    </p:spTree>
+    <p:extLst>
+      <p:ext uri="{BB962C8B-B14F-4D97-AF65-F5344CB8AC3E}">
+        <p14:creationId xmlns:p14="http://schemas.microsoft.com/office/powerpoint/2010/main" val="1024086991"/>
+      </p:ext>
+    </p:extLst>
+  </p:cSld>
+  <p:clrMapOvr>
+    <a:masterClrMapping/>
+  </p:clrMapOvr>
+</p:notes>
+</file>
+
 <file path=ppt/notesSlides/notesSlide2.xml><?xml version="1.0" encoding="utf-8"?>
 <p:notes xmlns:a="http://schemas.openxmlformats.org/drawingml/2006/main" xmlns:r="http://schemas.openxmlformats.org/officeDocument/2006/relationships" xmlns:p="http://schemas.openxmlformats.org/presentationml/2006/main">
   <p:cSld>
@@ -950,7 +1128,7 @@
           <a:p>
             <a:r>
               <a:rPr lang="en-US" dirty="0"/>
-              <a:t>De winst is TO minus TK = 500 euro. Het consumentensurplus is de driehoek boven de prijs en onder de vraaglijn = 200 euro. Vergelijk dit met volkomen concurrentie: de monopolist maakt meer winst, maar het CS is kleiner.</a:t>
+              <a:t>De monopolist produceert waar MO = MK (bij Q* = 20). De prijs leest hij af op de vraaglijn: p* = 30. LET OP: de prijs is 30, niet 10! De meestgemaakte fout is de prijs aflezen op de MK-lijn.</a:t>
             </a:r>
             <a:endParaRPr lang="en-US" dirty="0"/>
           </a:p>
@@ -1038,7 +1216,7 @@
           <a:p>
             <a:r>
               <a:rPr lang="en-US" dirty="0"/>
-              <a:t>Prijsdiscriminatie is een strategie die monopolisten gebruiken om meer winst te maken. Ze vragen verschillende prijzen aan verschillende groepen. Twee voorwaarden: groepen moeten te onderscheiden zijn en doorverkoop moet onmogelijk zijn.</a:t>
+              <a:t>De winst is TO minus TK = 500 euro. Het consumentensurplus is de driehoek boven de prijs en onder de vraaglijn = 200 euro. Vergelijk dit met volkomen concurrentie: de monopolist maakt meer winst, maar het CS is kleiner.</a:t>
             </a:r>
             <a:endParaRPr lang="en-US" dirty="0"/>
           </a:p>
@@ -1126,7 +1304,7 @@
           <a:p>
             <a:r>
               <a:rPr lang="en-US" dirty="0"/>
-              <a:t>De logica: door een lagere prijs te vragen aan groepen met een lagere betalingsbereidheid, krijg je extra klanten. Zolang de prijs boven de marginale kosten ligt, is elke extra verkoop winstgevend.</a:t>
+              <a:t>De groene rechthoek is de winst van de monopolist: (p* − GTK*) × Q* = (30 − 5) × 20 = 500. De blauwe driehoek is het consumentensurplus: ½ × 20 × (50 − 30) = 200. Vergelijk: bij volkomen concurrentie was CS = 2.000.</a:t>
             </a:r>
             <a:endParaRPr lang="en-US" dirty="0"/>
           </a:p>
@@ -1214,7 +1392,7 @@
           <a:p>
             <a:r>
               <a:rPr lang="en-US" dirty="0"/>
-              <a:t>Vijf kernpunten. Controleer of leerlingen de prijs op de vraaglijn aflezen, de MO-formule kennen, en begrijpen waarom prijsdiscriminatie winstgevend is.</a:t>
+              <a:t>Prijsdiscriminatie is een strategie die monopolisten gebruiken om meer winst te maken. Ze vragen verschillende prijzen aan verschillende groepen. Twee voorwaarden: groepen moeten te onderscheiden zijn en doorverkoop moet onmogelijk zijn.</a:t>
             </a:r>
             <a:endParaRPr lang="en-US" dirty="0"/>
           </a:p>
@@ -1831,6 +2009,743 @@
 </p:sld>
 </file>
 
+<file path=ppt/slides/slide10.xml><?xml version="1.0" encoding="utf-8"?>
+<p:sld xmlns:a="http://schemas.openxmlformats.org/drawingml/2006/main" xmlns:r="http://schemas.openxmlformats.org/officeDocument/2006/relationships" xmlns:p="http://schemas.openxmlformats.org/presentationml/2006/main">
+  <p:cSld name="Slide 10">
+    <p:spTree>
+      <p:nvGrpSpPr>
+        <p:cNvPr id="1" name=""/>
+        <p:cNvGrpSpPr/>
+        <p:nvPr/>
+      </p:nvGrpSpPr>
+      <p:grpSpPr>
+        <a:xfrm>
+          <a:off x="0" y="0"/>
+          <a:ext cx="0" cy="0"/>
+          <a:chOff x="0" y="0"/>
+          <a:chExt cx="0" cy="0"/>
+        </a:xfrm>
+      </p:grpSpPr>
+      <p:sp>
+        <p:nvSpPr>
+          <p:cNvPr id="2" name="Text 0"/>
+          <p:cNvSpPr/>
+          <p:nvPr/>
+        </p:nvSpPr>
+        <p:spPr>
+          <a:xfrm>
+            <a:off x="457200" y="0"/>
+            <a:ext cx="8229600" cy="685800"/>
+          </a:xfrm>
+          <a:prstGeom prst="rect">
+            <a:avLst/>
+          </a:prstGeom>
+          <a:noFill/>
+          <a:ln/>
+        </p:spPr>
+        <p:txBody>
+          <a:bodyPr wrap="square" rtlCol="0" anchor="ctr"/>
+          <a:lstStyle/>
+          <a:p>
+            <a:pPr indent="0" marL="0">
+              <a:buNone/>
+            </a:pPr>
+            <a:r>
+              <a:rPr lang="en-US" sz="2400" b="1" dirty="0">
+                <a:solidFill>
+                  <a:srgbClr val="FFFFFF"/>
+                </a:solidFill>
+                <a:latin typeface="Arial" pitchFamily="34" charset="0"/>
+                <a:ea typeface="Arial" pitchFamily="34" charset="-122"/>
+                <a:cs typeface="Arial" pitchFamily="34" charset="-120"/>
+              </a:rPr>
+              <a:t>Waarom levert prijsdiscriminatie meer winst?</a:t>
+            </a:r>
+            <a:endParaRPr lang="en-US" sz="2400" dirty="0"/>
+          </a:p>
+        </p:txBody>
+      </p:sp>
+      <p:sp>
+        <p:nvSpPr>
+          <p:cNvPr id="3" name="Shape 1"/>
+          <p:cNvSpPr/>
+          <p:nvPr/>
+        </p:nvSpPr>
+        <p:spPr>
+          <a:xfrm>
+            <a:off x="1371600" y="1097280"/>
+            <a:ext cx="6400800" cy="548640"/>
+          </a:xfrm>
+          <a:prstGeom prst="rect">
+            <a:avLst>
+              <a:gd name="adj" fmla="val 8333"/>
+            </a:avLst>
+          </a:prstGeom>
+          <a:solidFill>
+            <a:srgbClr val="F9F6F1"/>
+          </a:solidFill>
+          <a:ln/>
+          <a:effectLst>
+            <a:outerShdw sx="100000" sy="100000" kx="0" ky="0" algn="bl" rotWithShape="0" blurRad="76200" dist="25400" dir="8100000">
+              <a:srgbClr val="000000">
+                <a:alpha val="10000"/>
+              </a:srgbClr>
+            </a:outerShdw>
+          </a:effectLst>
+        </p:spPr>
+      </p:sp>
+      <p:sp>
+        <p:nvSpPr>
+          <p:cNvPr id="4" name="Text 2"/>
+          <p:cNvSpPr/>
+          <p:nvPr/>
+        </p:nvSpPr>
+        <p:spPr>
+          <a:xfrm>
+            <a:off x="1645920" y="1097280"/>
+            <a:ext cx="5852160" cy="548640"/>
+          </a:xfrm>
+          <a:prstGeom prst="rect">
+            <a:avLst/>
+          </a:prstGeom>
+          <a:noFill/>
+          <a:ln/>
+        </p:spPr>
+        <p:txBody>
+          <a:bodyPr wrap="square" rtlCol="0" anchor="ctr"/>
+          <a:lstStyle/>
+          <a:p>
+            <a:pPr indent="0" marL="0">
+              <a:buNone/>
+            </a:pPr>
+            <a:r>
+              <a:rPr lang="en-US" sz="1600" dirty="0">
+                <a:solidFill>
+                  <a:srgbClr val="2D3748"/>
+                </a:solidFill>
+                <a:latin typeface="Arial" pitchFamily="34" charset="0"/>
+                <a:ea typeface="Arial" pitchFamily="34" charset="-122"/>
+                <a:cs typeface="Arial" pitchFamily="34" charset="-120"/>
+              </a:rPr>
+              <a:t>Twee groepen onderscheiden</a:t>
+            </a:r>
+            <a:endParaRPr lang="en-US" sz="1600" dirty="0"/>
+          </a:p>
+        </p:txBody>
+      </p:sp>
+      <p:sp>
+        <p:nvSpPr>
+          <p:cNvPr id="5" name="Text 3"/>
+          <p:cNvSpPr/>
+          <p:nvPr/>
+        </p:nvSpPr>
+        <p:spPr>
+          <a:xfrm>
+            <a:off x="1371600" y="1645920"/>
+            <a:ext cx="6400800" cy="228600"/>
+          </a:xfrm>
+          <a:prstGeom prst="rect">
+            <a:avLst/>
+          </a:prstGeom>
+          <a:noFill/>
+          <a:ln/>
+        </p:spPr>
+        <p:txBody>
+          <a:bodyPr wrap="square" rtlCol="0" anchor="ctr"/>
+          <a:lstStyle/>
+          <a:p>
+            <a:pPr algn="ctr" indent="0" marL="0">
+              <a:buNone/>
+            </a:pPr>
+            <a:r>
+              <a:rPr lang="en-US" sz="1600" b="1" dirty="0">
+                <a:solidFill>
+                  <a:srgbClr val="1A5276"/>
+                </a:solidFill>
+                <a:latin typeface="Arial" pitchFamily="34" charset="0"/>
+                <a:ea typeface="Arial" pitchFamily="34" charset="-122"/>
+                <a:cs typeface="Arial" pitchFamily="34" charset="-120"/>
+              </a:rPr>
+              <a:t>↓</a:t>
+            </a:r>
+            <a:endParaRPr lang="en-US" sz="1600" dirty="0"/>
+          </a:p>
+        </p:txBody>
+      </p:sp>
+      <p:sp>
+        <p:nvSpPr>
+          <p:cNvPr id="6" name="Shape 4"/>
+          <p:cNvSpPr/>
+          <p:nvPr/>
+        </p:nvSpPr>
+        <p:spPr>
+          <a:xfrm>
+            <a:off x="1371600" y="1874520"/>
+            <a:ext cx="6400800" cy="548640"/>
+          </a:xfrm>
+          <a:prstGeom prst="rect">
+            <a:avLst>
+              <a:gd name="adj" fmla="val 8333"/>
+            </a:avLst>
+          </a:prstGeom>
+          <a:solidFill>
+            <a:srgbClr val="F9F6F1"/>
+          </a:solidFill>
+          <a:ln/>
+          <a:effectLst>
+            <a:outerShdw sx="100000" sy="100000" kx="0" ky="0" algn="bl" rotWithShape="0" blurRad="76200" dist="25400" dir="8100000">
+              <a:srgbClr val="000000">
+                <a:alpha val="10000"/>
+              </a:srgbClr>
+            </a:outerShdw>
+          </a:effectLst>
+        </p:spPr>
+      </p:sp>
+      <p:sp>
+        <p:nvSpPr>
+          <p:cNvPr id="7" name="Text 5"/>
+          <p:cNvSpPr/>
+          <p:nvPr/>
+        </p:nvSpPr>
+        <p:spPr>
+          <a:xfrm>
+            <a:off x="1645920" y="1874520"/>
+            <a:ext cx="5852160" cy="548640"/>
+          </a:xfrm>
+          <a:prstGeom prst="rect">
+            <a:avLst/>
+          </a:prstGeom>
+          <a:noFill/>
+          <a:ln/>
+        </p:spPr>
+        <p:txBody>
+          <a:bodyPr wrap="square" rtlCol="0" anchor="ctr"/>
+          <a:lstStyle/>
+          <a:p>
+            <a:pPr indent="0" marL="0">
+              <a:buNone/>
+            </a:pPr>
+            <a:r>
+              <a:rPr lang="en-US" sz="1600" dirty="0">
+                <a:solidFill>
+                  <a:srgbClr val="2D3748"/>
+                </a:solidFill>
+                <a:latin typeface="Arial" pitchFamily="34" charset="0"/>
+                <a:ea typeface="Arial" pitchFamily="34" charset="-122"/>
+                <a:cs typeface="Arial" pitchFamily="34" charset="-120"/>
+              </a:rPr>
+              <a:t>Lagere prijs voor groep met lagere betalingsbereidheid</a:t>
+            </a:r>
+            <a:endParaRPr lang="en-US" sz="1600" dirty="0"/>
+          </a:p>
+        </p:txBody>
+      </p:sp>
+      <p:sp>
+        <p:nvSpPr>
+          <p:cNvPr id="8" name="Text 6"/>
+          <p:cNvSpPr/>
+          <p:nvPr/>
+        </p:nvSpPr>
+        <p:spPr>
+          <a:xfrm>
+            <a:off x="1371600" y="2423160"/>
+            <a:ext cx="6400800" cy="228600"/>
+          </a:xfrm>
+          <a:prstGeom prst="rect">
+            <a:avLst/>
+          </a:prstGeom>
+          <a:noFill/>
+          <a:ln/>
+        </p:spPr>
+        <p:txBody>
+          <a:bodyPr wrap="square" rtlCol="0" anchor="ctr"/>
+          <a:lstStyle/>
+          <a:p>
+            <a:pPr algn="ctr" indent="0" marL="0">
+              <a:buNone/>
+            </a:pPr>
+            <a:r>
+              <a:rPr lang="en-US" sz="1600" b="1" dirty="0">
+                <a:solidFill>
+                  <a:srgbClr val="1A5276"/>
+                </a:solidFill>
+                <a:latin typeface="Arial" pitchFamily="34" charset="0"/>
+                <a:ea typeface="Arial" pitchFamily="34" charset="-122"/>
+                <a:cs typeface="Arial" pitchFamily="34" charset="-120"/>
+              </a:rPr>
+              <a:t>↓</a:t>
+            </a:r>
+            <a:endParaRPr lang="en-US" sz="1600" dirty="0"/>
+          </a:p>
+        </p:txBody>
+      </p:sp>
+      <p:sp>
+        <p:nvSpPr>
+          <p:cNvPr id="9" name="Shape 7"/>
+          <p:cNvSpPr/>
+          <p:nvPr/>
+        </p:nvSpPr>
+        <p:spPr>
+          <a:xfrm>
+            <a:off x="1371600" y="2651760"/>
+            <a:ext cx="6400800" cy="548640"/>
+          </a:xfrm>
+          <a:prstGeom prst="rect">
+            <a:avLst>
+              <a:gd name="adj" fmla="val 8333"/>
+            </a:avLst>
+          </a:prstGeom>
+          <a:solidFill>
+            <a:srgbClr val="EBF5FB"/>
+          </a:solidFill>
+          <a:ln/>
+          <a:effectLst>
+            <a:outerShdw sx="100000" sy="100000" kx="0" ky="0" algn="bl" rotWithShape="0" blurRad="76200" dist="25400" dir="8100000">
+              <a:srgbClr val="000000">
+                <a:alpha val="10000"/>
+              </a:srgbClr>
+            </a:outerShdw>
+          </a:effectLst>
+        </p:spPr>
+      </p:sp>
+      <p:sp>
+        <p:nvSpPr>
+          <p:cNvPr id="10" name="Text 8"/>
+          <p:cNvSpPr/>
+          <p:nvPr/>
+        </p:nvSpPr>
+        <p:spPr>
+          <a:xfrm>
+            <a:off x="1645920" y="2651760"/>
+            <a:ext cx="5852160" cy="548640"/>
+          </a:xfrm>
+          <a:prstGeom prst="rect">
+            <a:avLst/>
+          </a:prstGeom>
+          <a:noFill/>
+          <a:ln/>
+        </p:spPr>
+        <p:txBody>
+          <a:bodyPr wrap="square" rtlCol="0" anchor="ctr"/>
+          <a:lstStyle/>
+          <a:p>
+            <a:pPr indent="0" marL="0">
+              <a:buNone/>
+            </a:pPr>
+            <a:r>
+              <a:rPr lang="en-US" sz="1600" dirty="0">
+                <a:solidFill>
+                  <a:srgbClr val="2D3748"/>
+                </a:solidFill>
+                <a:latin typeface="Arial" pitchFamily="34" charset="0"/>
+                <a:ea typeface="Arial" pitchFamily="34" charset="-122"/>
+                <a:cs typeface="Arial" pitchFamily="34" charset="-120"/>
+              </a:rPr>
+              <a:t>Meer klanten (extra omzet)</a:t>
+            </a:r>
+            <a:endParaRPr lang="en-US" sz="1600" dirty="0"/>
+          </a:p>
+        </p:txBody>
+      </p:sp>
+      <p:sp>
+        <p:nvSpPr>
+          <p:cNvPr id="11" name="Text 9"/>
+          <p:cNvSpPr/>
+          <p:nvPr/>
+        </p:nvSpPr>
+        <p:spPr>
+          <a:xfrm>
+            <a:off x="1371600" y="3200400"/>
+            <a:ext cx="6400800" cy="228600"/>
+          </a:xfrm>
+          <a:prstGeom prst="rect">
+            <a:avLst/>
+          </a:prstGeom>
+          <a:noFill/>
+          <a:ln/>
+        </p:spPr>
+        <p:txBody>
+          <a:bodyPr wrap="square" rtlCol="0" anchor="ctr"/>
+          <a:lstStyle/>
+          <a:p>
+            <a:pPr algn="ctr" indent="0" marL="0">
+              <a:buNone/>
+            </a:pPr>
+            <a:r>
+              <a:rPr lang="en-US" sz="1600" b="1" dirty="0">
+                <a:solidFill>
+                  <a:srgbClr val="1A5276"/>
+                </a:solidFill>
+                <a:latin typeface="Arial" pitchFamily="34" charset="0"/>
+                <a:ea typeface="Arial" pitchFamily="34" charset="-122"/>
+                <a:cs typeface="Arial" pitchFamily="34" charset="-120"/>
+              </a:rPr>
+              <a:t>↓</a:t>
+            </a:r>
+            <a:endParaRPr lang="en-US" sz="1600" dirty="0"/>
+          </a:p>
+        </p:txBody>
+      </p:sp>
+      <p:sp>
+        <p:nvSpPr>
+          <p:cNvPr id="12" name="Shape 10"/>
+          <p:cNvSpPr/>
+          <p:nvPr/>
+        </p:nvSpPr>
+        <p:spPr>
+          <a:xfrm>
+            <a:off x="1371600" y="3429000"/>
+            <a:ext cx="6400800" cy="548640"/>
+          </a:xfrm>
+          <a:prstGeom prst="rect">
+            <a:avLst>
+              <a:gd name="adj" fmla="val 8333"/>
+            </a:avLst>
+          </a:prstGeom>
+          <a:solidFill>
+            <a:srgbClr val="1A5276"/>
+          </a:solidFill>
+          <a:ln/>
+          <a:effectLst>
+            <a:outerShdw sx="100000" sy="100000" kx="0" ky="0" algn="bl" rotWithShape="0" blurRad="76200" dist="25400" dir="8100000">
+              <a:srgbClr val="000000">
+                <a:alpha val="10000"/>
+              </a:srgbClr>
+            </a:outerShdw>
+          </a:effectLst>
+        </p:spPr>
+      </p:sp>
+      <p:sp>
+        <p:nvSpPr>
+          <p:cNvPr id="13" name="Text 11"/>
+          <p:cNvSpPr/>
+          <p:nvPr/>
+        </p:nvSpPr>
+        <p:spPr>
+          <a:xfrm>
+            <a:off x="1645920" y="3429000"/>
+            <a:ext cx="5852160" cy="548640"/>
+          </a:xfrm>
+          <a:prstGeom prst="rect">
+            <a:avLst/>
+          </a:prstGeom>
+          <a:noFill/>
+          <a:ln/>
+        </p:spPr>
+        <p:txBody>
+          <a:bodyPr wrap="square" rtlCol="0" anchor="ctr"/>
+          <a:lstStyle/>
+          <a:p>
+            <a:pPr indent="0" marL="0">
+              <a:buNone/>
+            </a:pPr>
+            <a:r>
+              <a:rPr lang="en-US" sz="1600" b="1" dirty="0">
+                <a:solidFill>
+                  <a:srgbClr val="FFFFFF"/>
+                </a:solidFill>
+                <a:latin typeface="Arial" pitchFamily="34" charset="0"/>
+                <a:ea typeface="Arial" pitchFamily="34" charset="-122"/>
+                <a:cs typeface="Arial" pitchFamily="34" charset="-120"/>
+              </a:rPr>
+              <a:t>Winst stijgt (zolang p &gt; MK)</a:t>
+            </a:r>
+            <a:endParaRPr lang="en-US" sz="1600" dirty="0"/>
+          </a:p>
+        </p:txBody>
+      </p:sp>
+      <p:sp>
+        <p:nvSpPr>
+          <p:cNvPr id="14" name="Text 12"/>
+          <p:cNvSpPr/>
+          <p:nvPr/>
+        </p:nvSpPr>
+        <p:spPr>
+          <a:xfrm>
+            <a:off x="640080" y="4206240"/>
+            <a:ext cx="7863840" cy="320040"/>
+          </a:xfrm>
+          <a:prstGeom prst="rect">
+            <a:avLst/>
+          </a:prstGeom>
+          <a:noFill/>
+          <a:ln/>
+        </p:spPr>
+        <p:txBody>
+          <a:bodyPr wrap="square" rtlCol="0" anchor="ctr"/>
+          <a:lstStyle/>
+          <a:p>
+            <a:pPr indent="0" marL="0">
+              <a:buNone/>
+            </a:pPr>
+            <a:r>
+              <a:rPr lang="en-US" sz="1300" i="1" dirty="0">
+                <a:solidFill>
+                  <a:srgbClr val="718096"/>
+                </a:solidFill>
+                <a:latin typeface="Arial" pitchFamily="34" charset="0"/>
+                <a:ea typeface="Arial" pitchFamily="34" charset="-122"/>
+                <a:cs typeface="Arial" pitchFamily="34" charset="-120"/>
+              </a:rPr>
+              <a:t>Jongeren betalen minder, maar nog boven de MK → winstgevend</a:t>
+            </a:r>
+            <a:endParaRPr lang="en-US" sz="1300" dirty="0"/>
+          </a:p>
+        </p:txBody>
+      </p:sp>
+    </p:spTree>
+  </p:cSld>
+  <p:clrMapOvr>
+    <a:masterClrMapping/>
+  </p:clrMapOvr>
+</p:sld>
+</file>
+
+<file path=ppt/slides/slide11.xml><?xml version="1.0" encoding="utf-8"?>
+<p:sld xmlns:a="http://schemas.openxmlformats.org/drawingml/2006/main" xmlns:r="http://schemas.openxmlformats.org/officeDocument/2006/relationships" xmlns:p="http://schemas.openxmlformats.org/presentationml/2006/main">
+  <p:cSld name="Slide 11">
+    <p:spTree>
+      <p:nvGrpSpPr>
+        <p:cNvPr id="1" name=""/>
+        <p:cNvGrpSpPr/>
+        <p:nvPr/>
+      </p:nvGrpSpPr>
+      <p:grpSpPr>
+        <a:xfrm>
+          <a:off x="0" y="0"/>
+          <a:ext cx="0" cy="0"/>
+          <a:chOff x="0" y="0"/>
+          <a:chExt cx="0" cy="0"/>
+        </a:xfrm>
+      </p:grpSpPr>
+      <p:sp>
+        <p:nvSpPr>
+          <p:cNvPr id="2" name="Text 0"/>
+          <p:cNvSpPr/>
+          <p:nvPr/>
+        </p:nvSpPr>
+        <p:spPr>
+          <a:xfrm>
+            <a:off x="640080" y="457200"/>
+            <a:ext cx="7863840" cy="640080"/>
+          </a:xfrm>
+          <a:prstGeom prst="rect">
+            <a:avLst/>
+          </a:prstGeom>
+          <a:noFill/>
+          <a:ln/>
+        </p:spPr>
+        <p:txBody>
+          <a:bodyPr wrap="square" rtlCol="0" anchor="ctr"/>
+          <a:lstStyle/>
+          <a:p>
+            <a:pPr indent="0" marL="0">
+              <a:buNone/>
+            </a:pPr>
+            <a:r>
+              <a:rPr lang="en-US" sz="2800" b="1" dirty="0">
+                <a:solidFill>
+                  <a:srgbClr val="FFFFFF"/>
+                </a:solidFill>
+                <a:latin typeface="Arial" pitchFamily="34" charset="0"/>
+                <a:ea typeface="Arial" pitchFamily="34" charset="-122"/>
+                <a:cs typeface="Arial" pitchFamily="34" charset="-120"/>
+              </a:rPr>
+              <a:t>Samenvatting</a:t>
+            </a:r>
+            <a:endParaRPr lang="en-US" sz="2800" dirty="0"/>
+          </a:p>
+        </p:txBody>
+      </p:sp>
+      <p:sp>
+        <p:nvSpPr>
+          <p:cNvPr id="3" name="Text 1"/>
+          <p:cNvSpPr/>
+          <p:nvPr/>
+        </p:nvSpPr>
+        <p:spPr>
+          <a:xfrm>
+            <a:off x="640080" y="1051560"/>
+            <a:ext cx="7863840" cy="365760"/>
+          </a:xfrm>
+          <a:prstGeom prst="rect">
+            <a:avLst/>
+          </a:prstGeom>
+          <a:noFill/>
+          <a:ln/>
+        </p:spPr>
+        <p:txBody>
+          <a:bodyPr wrap="square" rtlCol="0" anchor="ctr"/>
+          <a:lstStyle/>
+          <a:p>
+            <a:pPr indent="0" marL="0">
+              <a:buNone/>
+            </a:pPr>
+            <a:r>
+              <a:rPr lang="en-US" sz="1400" i="1" dirty="0">
+                <a:solidFill>
+                  <a:srgbClr val="718096"/>
+                </a:solidFill>
+                <a:latin typeface="Arial" pitchFamily="34" charset="0"/>
+                <a:ea typeface="Arial" pitchFamily="34" charset="-122"/>
+                <a:cs typeface="Arial" pitchFamily="34" charset="-120"/>
+              </a:rPr>
+              <a:t>Beheers je dit voordat je gaat oefenen?</a:t>
+            </a:r>
+            <a:endParaRPr lang="en-US" sz="1400" dirty="0"/>
+          </a:p>
+        </p:txBody>
+      </p:sp>
+      <p:sp>
+        <p:nvSpPr>
+          <p:cNvPr id="4" name="Text 2"/>
+          <p:cNvSpPr/>
+          <p:nvPr/>
+        </p:nvSpPr>
+        <p:spPr>
+          <a:xfrm>
+            <a:off x="640080" y="1554480"/>
+            <a:ext cx="7863840" cy="2926080"/>
+          </a:xfrm>
+          <a:prstGeom prst="rect">
+            <a:avLst/>
+          </a:prstGeom>
+          <a:noFill/>
+          <a:ln/>
+        </p:spPr>
+        <p:txBody>
+          <a:bodyPr wrap="square" rtlCol="0" anchor="t"/>
+          <a:lstStyle/>
+          <a:p>
+            <a:pPr marL="342900" indent="-342900">
+              <a:lnSpc>
+                <a:spcPct val="160000"/>
+              </a:lnSpc>
+              <a:spcAft>
+                <a:spcPts val="600"/>
+              </a:spcAft>
+              <a:buSzPct val="100000"/>
+              <a:buChar char="•"/>
+            </a:pPr>
+            <a:r>
+              <a:rPr lang="en-US" sz="1500" dirty="0">
+                <a:solidFill>
+                  <a:srgbClr val="FFFFFF"/>
+                </a:solidFill>
+                <a:latin typeface="Arial" pitchFamily="34" charset="0"/>
+                <a:ea typeface="Arial" pitchFamily="34" charset="-122"/>
+                <a:cs typeface="Arial" pitchFamily="34" charset="-120"/>
+              </a:rPr>
+              <a:t>De monopolist kiest zijn prijs op de vraaglijn (MO &lt; p)</a:t>
+            </a:r>
+            <a:endParaRPr lang="en-US" sz="1500" dirty="0"/>
+          </a:p>
+          <a:p>
+            <a:pPr marL="342900" indent="-342900">
+              <a:lnSpc>
+                <a:spcPct val="160000"/>
+              </a:lnSpc>
+              <a:spcAft>
+                <a:spcPts val="600"/>
+              </a:spcAft>
+              <a:buSzPct val="100000"/>
+              <a:buChar char="•"/>
+            </a:pPr>
+            <a:r>
+              <a:rPr lang="en-US" sz="1500" dirty="0">
+                <a:solidFill>
+                  <a:srgbClr val="FFFFFF"/>
+                </a:solidFill>
+                <a:latin typeface="Arial" pitchFamily="34" charset="0"/>
+                <a:ea typeface="Arial" pitchFamily="34" charset="-122"/>
+                <a:cs typeface="Arial" pitchFamily="34" charset="-120"/>
+              </a:rPr>
+              <a:t>MO heeft dubbele helling van V, zelfde startpunt</a:t>
+            </a:r>
+            <a:endParaRPr lang="en-US" sz="1500" dirty="0"/>
+          </a:p>
+          <a:p>
+            <a:pPr marL="342900" indent="-342900">
+              <a:lnSpc>
+                <a:spcPct val="160000"/>
+              </a:lnSpc>
+              <a:spcAft>
+                <a:spcPts val="600"/>
+              </a:spcAft>
+              <a:buSzPct val="100000"/>
+              <a:buChar char="•"/>
+            </a:pPr>
+            <a:r>
+              <a:rPr lang="en-US" sz="1500" dirty="0">
+                <a:solidFill>
+                  <a:srgbClr val="FFFFFF"/>
+                </a:solidFill>
+                <a:latin typeface="Arial" pitchFamily="34" charset="0"/>
+                <a:ea typeface="Arial" pitchFamily="34" charset="-122"/>
+                <a:cs typeface="Arial" pitchFamily="34" charset="-120"/>
+              </a:rPr>
+              <a:t>Winstmax: MO = MK → Q*, dan prijs aflezen op V</a:t>
+            </a:r>
+            <a:endParaRPr lang="en-US" sz="1500" dirty="0"/>
+          </a:p>
+          <a:p>
+            <a:pPr marL="342900" indent="-342900">
+              <a:lnSpc>
+                <a:spcPct val="160000"/>
+              </a:lnSpc>
+              <a:spcAft>
+                <a:spcPts val="600"/>
+              </a:spcAft>
+              <a:buSzPct val="100000"/>
+              <a:buChar char="•"/>
+            </a:pPr>
+            <a:r>
+              <a:rPr lang="en-US" sz="1500" dirty="0">
+                <a:solidFill>
+                  <a:srgbClr val="FFFFFF"/>
+                </a:solidFill>
+                <a:latin typeface="Arial" pitchFamily="34" charset="0"/>
+                <a:ea typeface="Arial" pitchFamily="34" charset="-122"/>
+                <a:cs typeface="Arial" pitchFamily="34" charset="-120"/>
+              </a:rPr>
+              <a:t>Winst = (p* − GTK) × Q*, CS = driehoek boven p*</a:t>
+            </a:r>
+            <a:endParaRPr lang="en-US" sz="1500" dirty="0"/>
+          </a:p>
+          <a:p>
+            <a:pPr marL="342900" indent="-342900">
+              <a:lnSpc>
+                <a:spcPct val="160000"/>
+              </a:lnSpc>
+              <a:spcAft>
+                <a:spcPts val="600"/>
+              </a:spcAft>
+              <a:buSzPct val="100000"/>
+              <a:buChar char="•"/>
+            </a:pPr>
+            <a:r>
+              <a:rPr lang="en-US" sz="1500" dirty="0">
+                <a:solidFill>
+                  <a:srgbClr val="FFFFFF"/>
+                </a:solidFill>
+                <a:latin typeface="Arial" pitchFamily="34" charset="0"/>
+                <a:ea typeface="Arial" pitchFamily="34" charset="-122"/>
+                <a:cs typeface="Arial" pitchFamily="34" charset="-120"/>
+              </a:rPr>
+              <a:t>Prijsdiscriminatie verhoogt de winst als p &gt; MK</a:t>
+            </a:r>
+            <a:endParaRPr lang="en-US" sz="1500" dirty="0"/>
+          </a:p>
+        </p:txBody>
+      </p:sp>
+    </p:spTree>
+  </p:cSld>
+  <p:clrMapOvr>
+    <a:masterClrMapping/>
+  </p:clrMapOvr>
+</p:sld>
+</file>
+
 <file path=ppt/slides/slide2.xml><?xml version="1.0" encoding="utf-8"?>
 <p:sld xmlns:a="http://schemas.openxmlformats.org/drawingml/2006/main" xmlns:r="http://schemas.openxmlformats.org/officeDocument/2006/relationships" xmlns:p="http://schemas.openxmlformats.org/presentationml/2006/main">
   <p:cSld name="Slide 2">
@@ -1910,7 +2825,7 @@
           <a:p>
             <a:pPr marL="342900" indent="-342900">
               <a:lnSpc>
-                <a:spcPct val="145000"/>
+                <a:spcPct val="140000"/>
               </a:lnSpc>
               <a:spcAft>
                 <a:spcPts val="600"/>
@@ -1919,7 +2834,7 @@
               <a:buChar char="•"/>
             </a:pPr>
             <a:r>
-              <a:rPr lang="en-US" sz="1600" dirty="0">
+              <a:rPr lang="en-US" sz="1500" dirty="0">
                 <a:solidFill>
                   <a:srgbClr val="2D3748"/>
                 </a:solidFill>
@@ -1929,12 +2844,12 @@
               </a:rPr>
               <a:t>De monopolist als prijszetter herkennen</a:t>
             </a:r>
-            <a:endParaRPr lang="en-US" sz="1600" dirty="0"/>
+            <a:endParaRPr lang="en-US" sz="1500" dirty="0"/>
           </a:p>
           <a:p>
             <a:pPr marL="342900" indent="-342900">
               <a:lnSpc>
-                <a:spcPct val="145000"/>
+                <a:spcPct val="140000"/>
               </a:lnSpc>
               <a:spcAft>
                 <a:spcPts val="600"/>
@@ -1943,7 +2858,7 @@
               <a:buChar char="•"/>
             </a:pPr>
             <a:r>
-              <a:rPr lang="en-US" sz="1600" dirty="0">
+              <a:rPr lang="en-US" sz="1500" dirty="0">
                 <a:solidFill>
                   <a:srgbClr val="2D3748"/>
                 </a:solidFill>
@@ -1953,12 +2868,12 @@
               </a:rPr>
               <a:t>MO, MK en GTK afleiden uit V en TK</a:t>
             </a:r>
-            <a:endParaRPr lang="en-US" sz="1600" dirty="0"/>
+            <a:endParaRPr lang="en-US" sz="1500" dirty="0"/>
           </a:p>
           <a:p>
             <a:pPr marL="342900" indent="-342900">
               <a:lnSpc>
-                <a:spcPct val="145000"/>
+                <a:spcPct val="140000"/>
               </a:lnSpc>
               <a:spcAft>
                 <a:spcPts val="600"/>
@@ -1967,7 +2882,7 @@
               <a:buChar char="•"/>
             </a:pPr>
             <a:r>
-              <a:rPr lang="en-US" sz="1600" dirty="0">
+              <a:rPr lang="en-US" sz="1500" dirty="0">
                 <a:solidFill>
                   <a:srgbClr val="2D3748"/>
                 </a:solidFill>
@@ -1977,12 +2892,12 @@
               </a:rPr>
               <a:t>Winstmaximalisatie toepassen: MO = MK</a:t>
             </a:r>
-            <a:endParaRPr lang="en-US" sz="1600" dirty="0"/>
+            <a:endParaRPr lang="en-US" sz="1500" dirty="0"/>
           </a:p>
           <a:p>
             <a:pPr marL="342900" indent="-342900">
               <a:lnSpc>
-                <a:spcPct val="145000"/>
+                <a:spcPct val="140000"/>
               </a:lnSpc>
               <a:spcAft>
                 <a:spcPts val="600"/>
@@ -1991,7 +2906,7 @@
               <a:buChar char="•"/>
             </a:pPr>
             <a:r>
-              <a:rPr lang="en-US" sz="1600" dirty="0">
+              <a:rPr lang="en-US" sz="1500" dirty="0">
                 <a:solidFill>
                   <a:srgbClr val="2D3748"/>
                 </a:solidFill>
@@ -2001,12 +2916,12 @@
               </a:rPr>
               <a:t>De monopoliegrafiek tekenen en lezen</a:t>
             </a:r>
-            <a:endParaRPr lang="en-US" sz="1600" dirty="0"/>
+            <a:endParaRPr lang="en-US" sz="1500" dirty="0"/>
           </a:p>
           <a:p>
             <a:pPr marL="342900" indent="-342900">
               <a:lnSpc>
-                <a:spcPct val="145000"/>
+                <a:spcPct val="140000"/>
               </a:lnSpc>
               <a:spcAft>
                 <a:spcPts val="600"/>
@@ -2015,7 +2930,7 @@
               <a:buChar char="•"/>
             </a:pPr>
             <a:r>
-              <a:rPr lang="en-US" sz="1600" dirty="0">
+              <a:rPr lang="en-US" sz="1500" dirty="0">
                 <a:solidFill>
                   <a:srgbClr val="2D3748"/>
                 </a:solidFill>
@@ -2025,12 +2940,12 @@
               </a:rPr>
               <a:t>Winst en CS bij monopolie berekenen</a:t>
             </a:r>
-            <a:endParaRPr lang="en-US" sz="1600" dirty="0"/>
+            <a:endParaRPr lang="en-US" sz="1500" dirty="0"/>
           </a:p>
           <a:p>
             <a:pPr marL="342900" indent="-342900">
               <a:lnSpc>
-                <a:spcPct val="145000"/>
+                <a:spcPct val="140000"/>
               </a:lnSpc>
               <a:spcAft>
                 <a:spcPts val="600"/>
@@ -2039,7 +2954,7 @@
               <a:buChar char="•"/>
             </a:pPr>
             <a:r>
-              <a:rPr lang="en-US" sz="1600" dirty="0">
+              <a:rPr lang="en-US" sz="1500" dirty="0">
                 <a:solidFill>
                   <a:srgbClr val="2D3748"/>
                 </a:solidFill>
@@ -2049,7 +2964,7 @@
               </a:rPr>
               <a:t>Prijsdiscriminatie herkennen en toepassen</a:t>
             </a:r>
-            <a:endParaRPr lang="en-US" sz="1600" dirty="0"/>
+            <a:endParaRPr lang="en-US" sz="1500" dirty="0"/>
           </a:p>
         </p:txBody>
       </p:sp>
@@ -2126,11 +3041,11 @@
         <p:spPr>
           <a:xfrm>
             <a:off x="457200" y="1005840"/>
-            <a:ext cx="8229600" cy="1005840"/>
+            <a:ext cx="3931920" cy="1828800"/>
           </a:xfrm>
           <a:prstGeom prst="rect">
             <a:avLst>
-              <a:gd name="adj" fmla="val 4545"/>
+              <a:gd name="adj" fmla="val 2500"/>
             </a:avLst>
           </a:prstGeom>
           <a:solidFill>
@@ -2155,13 +3070,13 @@
         <p:spPr>
           <a:xfrm>
             <a:off x="457200" y="1005840"/>
-            <a:ext cx="54864" cy="1005840"/>
+            <a:ext cx="54864" cy="1828800"/>
           </a:xfrm>
           <a:prstGeom prst="rect">
             <a:avLst/>
           </a:prstGeom>
           <a:solidFill>
-            <a:srgbClr val="1A5276"/>
+            <a:srgbClr val="7B2D8E"/>
           </a:solidFill>
           <a:ln/>
         </p:spPr>
@@ -2174,8 +3089,8 @@
         </p:nvSpPr>
         <p:spPr>
           <a:xfrm>
-            <a:off x="658368" y="1078992"/>
-            <a:ext cx="7772400" cy="365760"/>
+            <a:off x="640080" y="1143000"/>
+            <a:ext cx="3611880" cy="365760"/>
           </a:xfrm>
           <a:prstGeom prst="rect">
             <a:avLst/>
@@ -2184,7 +3099,7 @@
           <a:ln/>
         </p:spPr>
         <p:txBody>
-          <a:bodyPr wrap="square" rtlCol="0" anchor="ctr"/>
+          <a:bodyPr wrap="square" rtlCol="0" anchor="t"/>
           <a:lstStyle/>
           <a:p>
             <a:pPr indent="0" marL="0">
@@ -2193,7 +3108,7 @@
             <a:r>
               <a:rPr lang="en-US" sz="2000" b="1" dirty="0">
                 <a:solidFill>
-                  <a:srgbClr val="1A5276"/>
+                  <a:srgbClr val="7B2D8E"/>
                 </a:solidFill>
                 <a:latin typeface="Arial" pitchFamily="34" charset="0"/>
                 <a:ea typeface="Arial" pitchFamily="34" charset="-122"/>
@@ -2213,8 +3128,8 @@
         </p:nvSpPr>
         <p:spPr>
           <a:xfrm>
-            <a:off x="658368" y="1463040"/>
-            <a:ext cx="7772400" cy="457200"/>
+            <a:off x="640080" y="1554480"/>
+            <a:ext cx="3611880" cy="1143000"/>
           </a:xfrm>
           <a:prstGeom prst="rect">
             <a:avLst/>
@@ -2223,10 +3138,13 @@
           <a:ln/>
         </p:spPr>
         <p:txBody>
-          <a:bodyPr wrap="square" rtlCol="0" anchor="ctr"/>
-          <a:lstStyle/>
-          <a:p>
-            <a:pPr indent="0" marL="0">
+          <a:bodyPr wrap="square" rtlCol="0" anchor="t"/>
+          <a:lstStyle/>
+          <a:p>
+            <a:pPr algn="l" indent="0" marL="0">
+              <a:lnSpc>
+                <a:spcPct val="115000"/>
+              </a:lnSpc>
               <a:buNone/>
             </a:pPr>
             <a:r>
@@ -2252,12 +3170,12 @@
         </p:nvSpPr>
         <p:spPr>
           <a:xfrm>
-            <a:off x="457200" y="2194560"/>
-            <a:ext cx="8229600" cy="1005840"/>
+            <a:off x="4754880" y="1005840"/>
+            <a:ext cx="3931920" cy="1828800"/>
           </a:xfrm>
           <a:prstGeom prst="rect">
             <a:avLst>
-              <a:gd name="adj" fmla="val 4545"/>
+              <a:gd name="adj" fmla="val 2500"/>
             </a:avLst>
           </a:prstGeom>
           <a:solidFill>
@@ -2281,8 +3199,8 @@
         </p:nvSpPr>
         <p:spPr>
           <a:xfrm>
-            <a:off x="457200" y="2194560"/>
-            <a:ext cx="54864" cy="1005840"/>
+            <a:off x="4754880" y="1005840"/>
+            <a:ext cx="54864" cy="1828800"/>
           </a:xfrm>
           <a:prstGeom prst="rect">
             <a:avLst/>
@@ -2301,8 +3219,8 @@
         </p:nvSpPr>
         <p:spPr>
           <a:xfrm>
-            <a:off x="658368" y="2267712"/>
-            <a:ext cx="7772400" cy="365760"/>
+            <a:off x="4937760" y="1143000"/>
+            <a:ext cx="3611880" cy="365760"/>
           </a:xfrm>
           <a:prstGeom prst="rect">
             <a:avLst/>
@@ -2311,6 +3229,87 @@
           <a:ln/>
         </p:spPr>
         <p:txBody>
+          <a:bodyPr wrap="square" rtlCol="0" anchor="t"/>
+          <a:lstStyle/>
+          <a:p>
+            <a:pPr indent="0" marL="0">
+              <a:buNone/>
+            </a:pPr>
+            <a:r>
+              <a:rPr lang="en-US" sz="2000" b="1" dirty="0">
+                <a:solidFill>
+                  <a:srgbClr val="1A5276"/>
+                </a:solidFill>
+                <a:latin typeface="Arial" pitchFamily="34" charset="0"/>
+                <a:ea typeface="Arial" pitchFamily="34" charset="-122"/>
+                <a:cs typeface="Arial" pitchFamily="34" charset="-120"/>
+              </a:rPr>
+              <a:t>Vraaglijn = prijsafzetlijn</a:t>
+            </a:r>
+            <a:endParaRPr lang="en-US" sz="2000" dirty="0"/>
+          </a:p>
+        </p:txBody>
+      </p:sp>
+      <p:sp>
+        <p:nvSpPr>
+          <p:cNvPr id="10" name="Text 8"/>
+          <p:cNvSpPr/>
+          <p:nvPr/>
+        </p:nvSpPr>
+        <p:spPr>
+          <a:xfrm>
+            <a:off x="4937760" y="1554480"/>
+            <a:ext cx="3611880" cy="1143000"/>
+          </a:xfrm>
+          <a:prstGeom prst="rect">
+            <a:avLst/>
+          </a:prstGeom>
+          <a:noFill/>
+          <a:ln/>
+        </p:spPr>
+        <p:txBody>
+          <a:bodyPr wrap="square" rtlCol="0" anchor="t"/>
+          <a:lstStyle/>
+          <a:p>
+            <a:pPr algn="l" indent="0" marL="0">
+              <a:lnSpc>
+                <a:spcPct val="115000"/>
+              </a:lnSpc>
+              <a:buNone/>
+            </a:pPr>
+            <a:r>
+              <a:rPr lang="en-US" sz="1400" dirty="0">
+                <a:solidFill>
+                  <a:srgbClr val="2D3748"/>
+                </a:solidFill>
+                <a:latin typeface="Arial" pitchFamily="34" charset="0"/>
+                <a:ea typeface="Arial" pitchFamily="34" charset="-122"/>
+                <a:cs typeface="Arial" pitchFamily="34" charset="-120"/>
+              </a:rPr>
+              <a:t>De vraaglijn bepaalt welke prijs de monopolist kan vragen bij elke hoeveelheid.</a:t>
+            </a:r>
+            <a:endParaRPr lang="en-US" sz="1400" dirty="0"/>
+          </a:p>
+        </p:txBody>
+      </p:sp>
+      <p:sp>
+        <p:nvSpPr>
+          <p:cNvPr id="11" name="Text 9"/>
+          <p:cNvSpPr/>
+          <p:nvPr/>
+        </p:nvSpPr>
+        <p:spPr>
+          <a:xfrm>
+            <a:off x="457200" y="3200400"/>
+            <a:ext cx="8229600" cy="457200"/>
+          </a:xfrm>
+          <a:prstGeom prst="rect">
+            <a:avLst/>
+          </a:prstGeom>
+          <a:noFill/>
+          <a:ln/>
+        </p:spPr>
+        <p:txBody>
           <a:bodyPr wrap="square" rtlCol="0" anchor="ctr"/>
           <a:lstStyle/>
           <a:p>
@@ -2318,46 +3317,7 @@
               <a:buNone/>
             </a:pPr>
             <a:r>
-              <a:rPr lang="en-US" sz="2000" b="1" dirty="0">
-                <a:solidFill>
-                  <a:srgbClr val="1A5276"/>
-                </a:solidFill>
-                <a:latin typeface="Arial" pitchFamily="34" charset="0"/>
-                <a:ea typeface="Arial" pitchFamily="34" charset="-122"/>
-                <a:cs typeface="Arial" pitchFamily="34" charset="-120"/>
-              </a:rPr>
-              <a:t>Vraaglijn = prijsafzetlijn</a:t>
-            </a:r>
-            <a:endParaRPr lang="en-US" sz="2000" dirty="0"/>
-          </a:p>
-        </p:txBody>
-      </p:sp>
-      <p:sp>
-        <p:nvSpPr>
-          <p:cNvPr id="10" name="Text 8"/>
-          <p:cNvSpPr/>
-          <p:nvPr/>
-        </p:nvSpPr>
-        <p:spPr>
-          <a:xfrm>
-            <a:off x="658368" y="2651760"/>
-            <a:ext cx="7772400" cy="457200"/>
-          </a:xfrm>
-          <a:prstGeom prst="rect">
-            <a:avLst/>
-          </a:prstGeom>
-          <a:noFill/>
-          <a:ln/>
-        </p:spPr>
-        <p:txBody>
-          <a:bodyPr wrap="square" rtlCol="0" anchor="ctr"/>
-          <a:lstStyle/>
-          <a:p>
-            <a:pPr indent="0" marL="0">
-              <a:buNone/>
-            </a:pPr>
-            <a:r>
-              <a:rPr lang="en-US" sz="1400" dirty="0">
+              <a:rPr lang="en-US" sz="1500" b="1" dirty="0">
                 <a:solidFill>
                   <a:srgbClr val="2D3748"/>
                 </a:solidFill>
@@ -2365,109 +3325,7 @@
                 <a:ea typeface="Arial" pitchFamily="34" charset="-122"/>
                 <a:cs typeface="Arial" pitchFamily="34" charset="-120"/>
               </a:rPr>
-              <a:t>De vraaglijn bepaalt welke prijs de monopolist kan vragen bij elke hoeveelheid.</a:t>
-            </a:r>
-            <a:endParaRPr lang="en-US" sz="1400" dirty="0"/>
-          </a:p>
-        </p:txBody>
-      </p:sp>
-      <p:sp>
-        <p:nvSpPr>
-          <p:cNvPr id="11" name="Shape 9"/>
-          <p:cNvSpPr/>
-          <p:nvPr/>
-        </p:nvSpPr>
-        <p:spPr>
-          <a:xfrm>
-            <a:off x="457200" y="3566160"/>
-            <a:ext cx="8229600" cy="640080"/>
-          </a:xfrm>
-          <a:prstGeom prst="rect">
-            <a:avLst>
-              <a:gd name="adj" fmla="val 7143"/>
-            </a:avLst>
-          </a:prstGeom>
-          <a:solidFill>
-            <a:srgbClr val="EBF5FB"/>
-          </a:solidFill>
-          <a:ln/>
-          <a:effectLst>
-            <a:outerShdw sx="100000" sy="100000" kx="0" ky="0" algn="bl" rotWithShape="0" blurRad="76200" dist="25400" dir="8100000">
-              <a:srgbClr val="000000">
-                <a:alpha val="10000"/>
-              </a:srgbClr>
-            </a:outerShdw>
-          </a:effectLst>
-        </p:spPr>
-      </p:sp>
-      <p:sp>
-        <p:nvSpPr>
-          <p:cNvPr id="12" name="Shape 10"/>
-          <p:cNvSpPr/>
-          <p:nvPr/>
-        </p:nvSpPr>
-        <p:spPr>
-          <a:xfrm>
-            <a:off x="457200" y="3566160"/>
-            <a:ext cx="54864" cy="640080"/>
-          </a:xfrm>
-          <a:prstGeom prst="rect">
-            <a:avLst/>
-          </a:prstGeom>
-          <a:solidFill>
-            <a:srgbClr val="1A5276"/>
-          </a:solidFill>
-          <a:ln/>
-        </p:spPr>
-      </p:sp>
-      <p:sp>
-        <p:nvSpPr>
-          <p:cNvPr id="13" name="Text 11"/>
-          <p:cNvSpPr/>
-          <p:nvPr/>
-        </p:nvSpPr>
-        <p:spPr>
-          <a:xfrm>
-            <a:off x="658368" y="3566160"/>
-            <a:ext cx="7772400" cy="640080"/>
-          </a:xfrm>
-          <a:prstGeom prst="rect">
-            <a:avLst/>
-          </a:prstGeom>
-          <a:noFill/>
-          <a:ln/>
-        </p:spPr>
-        <p:txBody>
-          <a:bodyPr wrap="square" rtlCol="0" anchor="ctr"/>
-          <a:lstStyle/>
-          <a:p>
-            <a:pPr indent="0" marL="0">
-              <a:buNone/>
-            </a:pPr>
-            <a:r>
-              <a:rPr lang="en-US" sz="1500" b="1" dirty="0">
-                <a:solidFill>
-                  <a:srgbClr val="1A5276"/>
-                </a:solidFill>
-                <a:latin typeface="Arial" pitchFamily="34" charset="0"/>
-                <a:ea typeface="Arial" pitchFamily="34" charset="-122"/>
-                <a:cs typeface="Arial" pitchFamily="34" charset="-120"/>
-              </a:rPr>
-              <a:t>Kernpunt: </a:t>
-            </a:r>
-            <a:pPr indent="0" marL="0">
-              <a:buNone/>
-            </a:pPr>
-            <a:r>
-              <a:rPr lang="en-US" sz="1500" dirty="0">
-                <a:solidFill>
-                  <a:srgbClr val="2D3748"/>
-                </a:solidFill>
-                <a:latin typeface="Arial" pitchFamily="34" charset="0"/>
-                <a:ea typeface="Arial" pitchFamily="34" charset="-122"/>
-                <a:cs typeface="Arial" pitchFamily="34" charset="-120"/>
-              </a:rPr>
-              <a:t>Bij monopolie geldt MO &lt; p (de MO daalt sneller dan de prijs)</a:t>
+              <a:t>Kernpunt: Bij monopolie geldt MO &lt; p (de MO daalt sneller dan de prijs)</a:t>
             </a:r>
             <a:endParaRPr lang="en-US" sz="1500" dirty="0"/>
           </a:p>
@@ -2545,8 +3403,8 @@
         </p:nvSpPr>
         <p:spPr>
           <a:xfrm>
-            <a:off x="640080" y="868680"/>
-            <a:ext cx="7863840" cy="502920"/>
+            <a:off x="914400" y="868680"/>
+            <a:ext cx="7315200" cy="2926080"/>
           </a:xfrm>
           <a:prstGeom prst="rect">
             <a:avLst/>
@@ -2564,14 +3422,34 @@
       </p:sp>
       <p:sp>
         <p:nvSpPr>
-          <p:cNvPr id="4" name="Text 2"/>
-          <p:cNvSpPr/>
-          <p:nvPr/>
-        </p:nvSpPr>
-        <p:spPr>
-          <a:xfrm>
-            <a:off x="868680" y="868680"/>
-            <a:ext cx="1645920" cy="502920"/>
+          <p:cNvPr id="4" name="Shape 2"/>
+          <p:cNvSpPr/>
+          <p:nvPr/>
+        </p:nvSpPr>
+        <p:spPr>
+          <a:xfrm>
+            <a:off x="914400" y="868680"/>
+            <a:ext cx="54864" cy="2926080"/>
+          </a:xfrm>
+          <a:prstGeom prst="rect">
+            <a:avLst/>
+          </a:prstGeom>
+          <a:solidFill>
+            <a:srgbClr val="7B2D8E"/>
+          </a:solidFill>
+          <a:ln/>
+        </p:spPr>
+      </p:sp>
+      <p:sp>
+        <p:nvSpPr>
+          <p:cNvPr id="5" name="Text 3"/>
+          <p:cNvSpPr/>
+          <p:nvPr/>
+        </p:nvSpPr>
+        <p:spPr>
+          <a:xfrm>
+            <a:off x="1143000" y="960120"/>
+            <a:ext cx="6858000" cy="457200"/>
           </a:xfrm>
           <a:prstGeom prst="rect">
             <a:avLst/>
@@ -2595,33 +3473,8 @@
                 <a:ea typeface="Arial" pitchFamily="34" charset="-122"/>
                 <a:cs typeface="Arial" pitchFamily="34" charset="-120"/>
               </a:rPr>
-              <a:t>Vraaglijn</a:t>
-            </a:r>
-            <a:endParaRPr lang="en-US" sz="1300" dirty="0"/>
-          </a:p>
-        </p:txBody>
-      </p:sp>
-      <p:sp>
-        <p:nvSpPr>
-          <p:cNvPr id="5" name="Text 3"/>
-          <p:cNvSpPr/>
-          <p:nvPr/>
-        </p:nvSpPr>
-        <p:spPr>
-          <a:xfrm>
-            <a:off x="2560320" y="868680"/>
-            <a:ext cx="5669280" cy="502920"/>
-          </a:xfrm>
-          <a:prstGeom prst="rect">
-            <a:avLst/>
-          </a:prstGeom>
-          <a:noFill/>
-          <a:ln/>
-        </p:spPr>
-        <p:txBody>
-          <a:bodyPr wrap="square" rtlCol="0" anchor="ctr"/>
-          <a:lstStyle/>
-          <a:p>
+              <a:t>Vraaglijn:  </a:t>
+            </a:r>
             <a:pPr indent="0" marL="0">
               <a:buNone/>
             </a:pPr>
@@ -2636,45 +3489,20 @@
               </a:rPr>
               <a:t>V: p = −Q + 50</a:t>
             </a:r>
-            <a:endParaRPr lang="en-US" sz="1500" dirty="0"/>
-          </a:p>
-        </p:txBody>
-      </p:sp>
-      <p:sp>
-        <p:nvSpPr>
-          <p:cNvPr id="6" name="Shape 4"/>
-          <p:cNvSpPr/>
-          <p:nvPr/>
-        </p:nvSpPr>
-        <p:spPr>
-          <a:xfrm>
-            <a:off x="640080" y="1508760"/>
-            <a:ext cx="7863840" cy="502920"/>
-          </a:xfrm>
-          <a:prstGeom prst="rect">
-            <a:avLst/>
-          </a:prstGeom>
-          <a:solidFill>
-            <a:srgbClr val="F7F8FA"/>
-          </a:solidFill>
-          <a:ln w="6350">
-            <a:solidFill>
-              <a:srgbClr val="CBD5E0"/>
-            </a:solidFill>
-            <a:prstDash val="solid"/>
-          </a:ln>
-        </p:spPr>
-      </p:sp>
-      <p:sp>
-        <p:nvSpPr>
-          <p:cNvPr id="7" name="Text 5"/>
-          <p:cNvSpPr/>
-          <p:nvPr/>
-        </p:nvSpPr>
-        <p:spPr>
-          <a:xfrm>
-            <a:off x="868680" y="1508760"/>
-            <a:ext cx="1645920" cy="502920"/>
+            <a:endParaRPr lang="en-US" sz="1300" dirty="0"/>
+          </a:p>
+        </p:txBody>
+      </p:sp>
+      <p:sp>
+        <p:nvSpPr>
+          <p:cNvPr id="6" name="Text 4"/>
+          <p:cNvSpPr/>
+          <p:nvPr/>
+        </p:nvSpPr>
+        <p:spPr>
+          <a:xfrm>
+            <a:off x="1143000" y="1417320"/>
+            <a:ext cx="6858000" cy="457200"/>
           </a:xfrm>
           <a:prstGeom prst="rect">
             <a:avLst/>
@@ -2698,33 +3526,8 @@
                 <a:ea typeface="Arial" pitchFamily="34" charset="-122"/>
                 <a:cs typeface="Arial" pitchFamily="34" charset="-120"/>
               </a:rPr>
-              <a:t>TO</a:t>
-            </a:r>
-            <a:endParaRPr lang="en-US" sz="1300" dirty="0"/>
-          </a:p>
-        </p:txBody>
-      </p:sp>
-      <p:sp>
-        <p:nvSpPr>
-          <p:cNvPr id="8" name="Text 6"/>
-          <p:cNvSpPr/>
-          <p:nvPr/>
-        </p:nvSpPr>
-        <p:spPr>
-          <a:xfrm>
-            <a:off x="2560320" y="1508760"/>
-            <a:ext cx="5669280" cy="502920"/>
-          </a:xfrm>
-          <a:prstGeom prst="rect">
-            <a:avLst/>
-          </a:prstGeom>
-          <a:noFill/>
-          <a:ln/>
-        </p:spPr>
-        <p:txBody>
-          <a:bodyPr wrap="square" rtlCol="0" anchor="ctr"/>
-          <a:lstStyle/>
-          <a:p>
+              <a:t>TO:  </a:t>
+            </a:r>
             <a:pPr indent="0" marL="0">
               <a:buNone/>
             </a:pPr>
@@ -2739,65 +3542,20 @@
               </a:rPr>
               <a:t>TO = p × Q = (−Q + 50) × Q = −Q² + 50Q</a:t>
             </a:r>
-            <a:endParaRPr lang="en-US" sz="1500" dirty="0"/>
-          </a:p>
-        </p:txBody>
-      </p:sp>
-      <p:sp>
-        <p:nvSpPr>
-          <p:cNvPr id="9" name="Shape 7"/>
-          <p:cNvSpPr/>
-          <p:nvPr/>
-        </p:nvSpPr>
-        <p:spPr>
-          <a:xfrm>
-            <a:off x="640080" y="2148840"/>
-            <a:ext cx="7863840" cy="502920"/>
-          </a:xfrm>
-          <a:prstGeom prst="rect">
-            <a:avLst/>
-          </a:prstGeom>
-          <a:solidFill>
-            <a:srgbClr val="EBF5FB"/>
-          </a:solidFill>
-          <a:ln w="6350">
-            <a:solidFill>
-              <a:srgbClr val="1A5276"/>
-            </a:solidFill>
-            <a:prstDash val="solid"/>
-          </a:ln>
-        </p:spPr>
-      </p:sp>
-      <p:sp>
-        <p:nvSpPr>
-          <p:cNvPr id="10" name="Shape 8"/>
-          <p:cNvSpPr/>
-          <p:nvPr/>
-        </p:nvSpPr>
-        <p:spPr>
-          <a:xfrm>
-            <a:off x="640080" y="2148840"/>
-            <a:ext cx="54864" cy="502920"/>
-          </a:xfrm>
-          <a:prstGeom prst="rect">
-            <a:avLst/>
-          </a:prstGeom>
-          <a:solidFill>
-            <a:srgbClr val="1A5276"/>
-          </a:solidFill>
-          <a:ln/>
-        </p:spPr>
-      </p:sp>
-      <p:sp>
-        <p:nvSpPr>
-          <p:cNvPr id="11" name="Text 9"/>
-          <p:cNvSpPr/>
-          <p:nvPr/>
-        </p:nvSpPr>
-        <p:spPr>
-          <a:xfrm>
-            <a:off x="868680" y="2148840"/>
-            <a:ext cx="1645920" cy="502920"/>
+            <a:endParaRPr lang="en-US" sz="1300" dirty="0"/>
+          </a:p>
+        </p:txBody>
+      </p:sp>
+      <p:sp>
+        <p:nvSpPr>
+          <p:cNvPr id="7" name="Text 5"/>
+          <p:cNvSpPr/>
+          <p:nvPr/>
+        </p:nvSpPr>
+        <p:spPr>
+          <a:xfrm>
+            <a:off x="1143000" y="1874520"/>
+            <a:ext cx="6858000" cy="457200"/>
           </a:xfrm>
           <a:prstGeom prst="rect">
             <a:avLst/>
@@ -2815,44 +3573,19 @@
             <a:r>
               <a:rPr lang="en-US" sz="1300" b="1" dirty="0">
                 <a:solidFill>
-                  <a:srgbClr val="1A5276"/>
-                </a:solidFill>
-                <a:latin typeface="Arial" pitchFamily="34" charset="0"/>
-                <a:ea typeface="Arial" pitchFamily="34" charset="-122"/>
-                <a:cs typeface="Arial" pitchFamily="34" charset="-120"/>
-              </a:rPr>
-              <a:t>MO</a:t>
-            </a:r>
-            <a:endParaRPr lang="en-US" sz="1300" dirty="0"/>
-          </a:p>
-        </p:txBody>
-      </p:sp>
-      <p:sp>
-        <p:nvSpPr>
-          <p:cNvPr id="12" name="Text 10"/>
-          <p:cNvSpPr/>
-          <p:nvPr/>
-        </p:nvSpPr>
-        <p:spPr>
-          <a:xfrm>
-            <a:off x="2560320" y="2148840"/>
-            <a:ext cx="5669280" cy="502920"/>
-          </a:xfrm>
-          <a:prstGeom prst="rect">
-            <a:avLst/>
-          </a:prstGeom>
-          <a:noFill/>
-          <a:ln/>
-        </p:spPr>
-        <p:txBody>
-          <a:bodyPr wrap="square" rtlCol="0" anchor="ctr"/>
-          <a:lstStyle/>
-          <a:p>
+                  <a:srgbClr val="718096"/>
+                </a:solidFill>
+                <a:latin typeface="Arial" pitchFamily="34" charset="0"/>
+                <a:ea typeface="Arial" pitchFamily="34" charset="-122"/>
+                <a:cs typeface="Arial" pitchFamily="34" charset="-120"/>
+              </a:rPr>
+              <a:t>MO:  </a:t>
+            </a:r>
             <a:pPr indent="0" marL="0">
               <a:buNone/>
             </a:pPr>
             <a:r>
-              <a:rPr lang="en-US" sz="1500" b="1" dirty="0">
+              <a:rPr lang="en-US" sz="1500" dirty="0">
                 <a:solidFill>
                   <a:srgbClr val="2D3748"/>
                 </a:solidFill>
@@ -2862,45 +3595,20 @@
               </a:rPr>
               <a:t>MO = TO′ = −2Q + 50</a:t>
             </a:r>
-            <a:endParaRPr lang="en-US" sz="1500" dirty="0"/>
-          </a:p>
-        </p:txBody>
-      </p:sp>
-      <p:sp>
-        <p:nvSpPr>
-          <p:cNvPr id="13" name="Shape 11"/>
-          <p:cNvSpPr/>
-          <p:nvPr/>
-        </p:nvSpPr>
-        <p:spPr>
-          <a:xfrm>
-            <a:off x="640080" y="2788920"/>
-            <a:ext cx="7863840" cy="502920"/>
-          </a:xfrm>
-          <a:prstGeom prst="rect">
-            <a:avLst/>
-          </a:prstGeom>
-          <a:solidFill>
-            <a:srgbClr val="F7F8FA"/>
-          </a:solidFill>
-          <a:ln w="6350">
-            <a:solidFill>
-              <a:srgbClr val="CBD5E0"/>
-            </a:solidFill>
-            <a:prstDash val="solid"/>
-          </a:ln>
-        </p:spPr>
-      </p:sp>
-      <p:sp>
-        <p:nvSpPr>
-          <p:cNvPr id="14" name="Text 12"/>
-          <p:cNvSpPr/>
-          <p:nvPr/>
-        </p:nvSpPr>
-        <p:spPr>
-          <a:xfrm>
-            <a:off x="868680" y="2788920"/>
-            <a:ext cx="1645920" cy="502920"/>
+            <a:endParaRPr lang="en-US" sz="1300" dirty="0"/>
+          </a:p>
+        </p:txBody>
+      </p:sp>
+      <p:sp>
+        <p:nvSpPr>
+          <p:cNvPr id="8" name="Text 6"/>
+          <p:cNvSpPr/>
+          <p:nvPr/>
+        </p:nvSpPr>
+        <p:spPr>
+          <a:xfrm>
+            <a:off x="1143000" y="2331720"/>
+            <a:ext cx="6858000" cy="457200"/>
           </a:xfrm>
           <a:prstGeom prst="rect">
             <a:avLst/>
@@ -2924,33 +3632,8 @@
                 <a:ea typeface="Arial" pitchFamily="34" charset="-122"/>
                 <a:cs typeface="Arial" pitchFamily="34" charset="-120"/>
               </a:rPr>
-              <a:t>TK</a:t>
-            </a:r>
-            <a:endParaRPr lang="en-US" sz="1300" dirty="0"/>
-          </a:p>
-        </p:txBody>
-      </p:sp>
-      <p:sp>
-        <p:nvSpPr>
-          <p:cNvPr id="15" name="Text 13"/>
-          <p:cNvSpPr/>
-          <p:nvPr/>
-        </p:nvSpPr>
-        <p:spPr>
-          <a:xfrm>
-            <a:off x="2560320" y="2788920"/>
-            <a:ext cx="5669280" cy="502920"/>
-          </a:xfrm>
-          <a:prstGeom prst="rect">
-            <a:avLst/>
-          </a:prstGeom>
-          <a:noFill/>
-          <a:ln/>
-        </p:spPr>
-        <p:txBody>
-          <a:bodyPr wrap="square" rtlCol="0" anchor="ctr"/>
-          <a:lstStyle/>
-          <a:p>
+              <a:t>TK:  </a:t>
+            </a:r>
             <a:pPr indent="0" marL="0">
               <a:buNone/>
             </a:pPr>
@@ -2965,45 +3648,20 @@
               </a:rPr>
               <a:t>TK = 0,25Q²</a:t>
             </a:r>
-            <a:endParaRPr lang="en-US" sz="1500" dirty="0"/>
-          </a:p>
-        </p:txBody>
-      </p:sp>
-      <p:sp>
-        <p:nvSpPr>
-          <p:cNvPr id="16" name="Shape 14"/>
-          <p:cNvSpPr/>
-          <p:nvPr/>
-        </p:nvSpPr>
-        <p:spPr>
-          <a:xfrm>
-            <a:off x="640080" y="3429000"/>
-            <a:ext cx="7863840" cy="502920"/>
-          </a:xfrm>
-          <a:prstGeom prst="rect">
-            <a:avLst/>
-          </a:prstGeom>
-          <a:solidFill>
-            <a:srgbClr val="F7F8FA"/>
-          </a:solidFill>
-          <a:ln w="6350">
-            <a:solidFill>
-              <a:srgbClr val="CBD5E0"/>
-            </a:solidFill>
-            <a:prstDash val="solid"/>
-          </a:ln>
-        </p:spPr>
-      </p:sp>
-      <p:sp>
-        <p:nvSpPr>
-          <p:cNvPr id="17" name="Text 15"/>
-          <p:cNvSpPr/>
-          <p:nvPr/>
-        </p:nvSpPr>
-        <p:spPr>
-          <a:xfrm>
-            <a:off x="868680" y="3429000"/>
-            <a:ext cx="1645920" cy="502920"/>
+            <a:endParaRPr lang="en-US" sz="1300" dirty="0"/>
+          </a:p>
+        </p:txBody>
+      </p:sp>
+      <p:sp>
+        <p:nvSpPr>
+          <p:cNvPr id="9" name="Text 7"/>
+          <p:cNvSpPr/>
+          <p:nvPr/>
+        </p:nvSpPr>
+        <p:spPr>
+          <a:xfrm>
+            <a:off x="1143000" y="2788920"/>
+            <a:ext cx="6858000" cy="457200"/>
           </a:xfrm>
           <a:prstGeom prst="rect">
             <a:avLst/>
@@ -3027,33 +3685,8 @@
                 <a:ea typeface="Arial" pitchFamily="34" charset="-122"/>
                 <a:cs typeface="Arial" pitchFamily="34" charset="-120"/>
               </a:rPr>
-              <a:t>MK</a:t>
-            </a:r>
-            <a:endParaRPr lang="en-US" sz="1300" dirty="0"/>
-          </a:p>
-        </p:txBody>
-      </p:sp>
-      <p:sp>
-        <p:nvSpPr>
-          <p:cNvPr id="18" name="Text 16"/>
-          <p:cNvSpPr/>
-          <p:nvPr/>
-        </p:nvSpPr>
-        <p:spPr>
-          <a:xfrm>
-            <a:off x="2560320" y="3429000"/>
-            <a:ext cx="5669280" cy="502920"/>
-          </a:xfrm>
-          <a:prstGeom prst="rect">
-            <a:avLst/>
-          </a:prstGeom>
-          <a:noFill/>
-          <a:ln/>
-        </p:spPr>
-        <p:txBody>
-          <a:bodyPr wrap="square" rtlCol="0" anchor="ctr"/>
-          <a:lstStyle/>
-          <a:p>
+              <a:t>MK:  </a:t>
+            </a:r>
             <a:pPr indent="0" marL="0">
               <a:buNone/>
             </a:pPr>
@@ -3068,45 +3701,20 @@
               </a:rPr>
               <a:t>MK = TK′ = 0,5Q</a:t>
             </a:r>
-            <a:endParaRPr lang="en-US" sz="1500" dirty="0"/>
-          </a:p>
-        </p:txBody>
-      </p:sp>
-      <p:sp>
-        <p:nvSpPr>
-          <p:cNvPr id="19" name="Shape 17"/>
-          <p:cNvSpPr/>
-          <p:nvPr/>
-        </p:nvSpPr>
-        <p:spPr>
-          <a:xfrm>
-            <a:off x="640080" y="4069080"/>
-            <a:ext cx="7863840" cy="502920"/>
-          </a:xfrm>
-          <a:prstGeom prst="rect">
-            <a:avLst/>
-          </a:prstGeom>
-          <a:solidFill>
-            <a:srgbClr val="F7F8FA"/>
-          </a:solidFill>
-          <a:ln w="6350">
-            <a:solidFill>
-              <a:srgbClr val="CBD5E0"/>
-            </a:solidFill>
-            <a:prstDash val="solid"/>
-          </a:ln>
-        </p:spPr>
-      </p:sp>
-      <p:sp>
-        <p:nvSpPr>
-          <p:cNvPr id="20" name="Text 18"/>
-          <p:cNvSpPr/>
-          <p:nvPr/>
-        </p:nvSpPr>
-        <p:spPr>
-          <a:xfrm>
-            <a:off x="868680" y="4069080"/>
-            <a:ext cx="1645920" cy="502920"/>
+            <a:endParaRPr lang="en-US" sz="1300" dirty="0"/>
+          </a:p>
+        </p:txBody>
+      </p:sp>
+      <p:sp>
+        <p:nvSpPr>
+          <p:cNvPr id="10" name="Text 8"/>
+          <p:cNvSpPr/>
+          <p:nvPr/>
+        </p:nvSpPr>
+        <p:spPr>
+          <a:xfrm>
+            <a:off x="1143000" y="3246120"/>
+            <a:ext cx="6858000" cy="457200"/>
           </a:xfrm>
           <a:prstGeom prst="rect">
             <a:avLst/>
@@ -3130,33 +3738,8 @@
                 <a:ea typeface="Arial" pitchFamily="34" charset="-122"/>
                 <a:cs typeface="Arial" pitchFamily="34" charset="-120"/>
               </a:rPr>
-              <a:t>GTK</a:t>
-            </a:r>
-            <a:endParaRPr lang="en-US" sz="1300" dirty="0"/>
-          </a:p>
-        </p:txBody>
-      </p:sp>
-      <p:sp>
-        <p:nvSpPr>
-          <p:cNvPr id="21" name="Text 19"/>
-          <p:cNvSpPr/>
-          <p:nvPr/>
-        </p:nvSpPr>
-        <p:spPr>
-          <a:xfrm>
-            <a:off x="2560320" y="4069080"/>
-            <a:ext cx="5669280" cy="502920"/>
-          </a:xfrm>
-          <a:prstGeom prst="rect">
-            <a:avLst/>
-          </a:prstGeom>
-          <a:noFill/>
-          <a:ln/>
-        </p:spPr>
-        <p:txBody>
-          <a:bodyPr wrap="square" rtlCol="0" anchor="ctr"/>
-          <a:lstStyle/>
-          <a:p>
+              <a:t>GTK:  </a:t>
+            </a:r>
             <a:pPr indent="0" marL="0">
               <a:buNone/>
             </a:pPr>
@@ -3171,7 +3754,7 @@
               </a:rPr>
               <a:t>GTK = TK/Q = 0,25Q</a:t>
             </a:r>
-            <a:endParaRPr lang="en-US" sz="1500" dirty="0"/>
+            <a:endParaRPr lang="en-US" sz="1300" dirty="0"/>
           </a:p>
         </p:txBody>
       </p:sp>
@@ -3247,25 +3830,21 @@
         </p:nvSpPr>
         <p:spPr>
           <a:xfrm>
-            <a:off x="457200" y="1005840"/>
-            <a:ext cx="3931920" cy="1188720"/>
-          </a:xfrm>
-          <a:prstGeom prst="rect">
-            <a:avLst>
-              <a:gd name="adj" fmla="val 3846"/>
-            </a:avLst>
+            <a:off x="1143000" y="1005840"/>
+            <a:ext cx="6858000" cy="2377440"/>
+          </a:xfrm>
+          <a:prstGeom prst="rect">
+            <a:avLst/>
           </a:prstGeom>
           <a:solidFill>
-            <a:srgbClr val="F9F6F1"/>
+            <a:srgbClr val="F7F8FA"/>
           </a:solidFill>
-          <a:ln/>
-          <a:effectLst>
-            <a:outerShdw sx="100000" sy="100000" kx="0" ky="0" algn="bl" rotWithShape="0" blurRad="76200" dist="25400" dir="8100000">
-              <a:srgbClr val="000000">
-                <a:alpha val="10000"/>
-              </a:srgbClr>
-            </a:outerShdw>
-          </a:effectLst>
+          <a:ln w="6350">
+            <a:solidFill>
+              <a:srgbClr val="CBD5E0"/>
+            </a:solidFill>
+            <a:prstDash val="solid"/>
+          </a:ln>
         </p:spPr>
       </p:sp>
       <p:sp>
@@ -3276,14 +3855,14 @@
         </p:nvSpPr>
         <p:spPr>
           <a:xfrm>
-            <a:off x="457200" y="1005840"/>
-            <a:ext cx="54864" cy="1188720"/>
+            <a:off x="1143000" y="1005840"/>
+            <a:ext cx="54864" cy="2377440"/>
           </a:xfrm>
           <a:prstGeom prst="rect">
             <a:avLst/>
           </a:prstGeom>
           <a:solidFill>
-            <a:srgbClr val="718096"/>
+            <a:srgbClr val="7B2D8E"/>
           </a:solidFill>
           <a:ln/>
         </p:spPr>
@@ -3296,8 +3875,8 @@
         </p:nvSpPr>
         <p:spPr>
           <a:xfrm>
-            <a:off x="640080" y="1097280"/>
-            <a:ext cx="3566160" cy="365760"/>
+            <a:off x="1371600" y="1097280"/>
+            <a:ext cx="6400800" cy="548640"/>
           </a:xfrm>
           <a:prstGeom prst="rect">
             <a:avLst/>
@@ -3313,41 +3892,16 @@
               <a:buNone/>
             </a:pPr>
             <a:r>
-              <a:rPr lang="en-US" sz="1600" b="1" dirty="0">
-                <a:solidFill>
-                  <a:srgbClr val="2D3748"/>
-                </a:solidFill>
-                <a:latin typeface="Arial" pitchFamily="34" charset="0"/>
-                <a:ea typeface="Arial" pitchFamily="34" charset="-122"/>
-                <a:cs typeface="Arial" pitchFamily="34" charset="-120"/>
-              </a:rPr>
-              <a:t>Stap 1: MO = MK</a:t>
-            </a:r>
-            <a:endParaRPr lang="en-US" sz="1600" dirty="0"/>
-          </a:p>
-        </p:txBody>
-      </p:sp>
-      <p:sp>
-        <p:nvSpPr>
-          <p:cNvPr id="6" name="Text 4"/>
-          <p:cNvSpPr/>
-          <p:nvPr/>
-        </p:nvSpPr>
-        <p:spPr>
-          <a:xfrm>
-            <a:off x="640080" y="1508760"/>
-            <a:ext cx="3566160" cy="548640"/>
-          </a:xfrm>
-          <a:prstGeom prst="rect">
-            <a:avLst/>
-          </a:prstGeom>
-          <a:noFill/>
-          <a:ln/>
-        </p:spPr>
-        <p:txBody>
-          <a:bodyPr wrap="square" rtlCol="0" anchor="ctr"/>
-          <a:lstStyle/>
-          <a:p>
+              <a:rPr lang="en-US" sz="1400" b="1" dirty="0">
+                <a:solidFill>
+                  <a:srgbClr val="718096"/>
+                </a:solidFill>
+                <a:latin typeface="Arial" pitchFamily="34" charset="0"/>
+                <a:ea typeface="Arial" pitchFamily="34" charset="-122"/>
+                <a:cs typeface="Arial" pitchFamily="34" charset="-120"/>
+              </a:rPr>
+              <a:t>Stap 1: MO = MK:  </a:t>
+            </a:r>
             <a:pPr indent="0" marL="0">
               <a:buNone/>
             </a:pPr>
@@ -3362,69 +3916,20 @@
               </a:rPr>
               <a:t>−2Q + 50 = 0,5Q</a:t>
             </a:r>
-            <a:endParaRPr lang="en-US" sz="1700" dirty="0"/>
-          </a:p>
-        </p:txBody>
-      </p:sp>
-      <p:sp>
-        <p:nvSpPr>
-          <p:cNvPr id="7" name="Shape 5"/>
-          <p:cNvSpPr/>
-          <p:nvPr/>
-        </p:nvSpPr>
-        <p:spPr>
-          <a:xfrm>
-            <a:off x="4754880" y="1005840"/>
-            <a:ext cx="3931920" cy="1188720"/>
-          </a:xfrm>
-          <a:prstGeom prst="rect">
-            <a:avLst>
-              <a:gd name="adj" fmla="val 3846"/>
-            </a:avLst>
-          </a:prstGeom>
-          <a:solidFill>
-            <a:srgbClr val="F9F6F1"/>
-          </a:solidFill>
-          <a:ln/>
-          <a:effectLst>
-            <a:outerShdw sx="100000" sy="100000" kx="0" ky="0" algn="bl" rotWithShape="0" blurRad="76200" dist="25400" dir="8100000">
-              <a:srgbClr val="000000">
-                <a:alpha val="10000"/>
-              </a:srgbClr>
-            </a:outerShdw>
-          </a:effectLst>
-        </p:spPr>
-      </p:sp>
-      <p:sp>
-        <p:nvSpPr>
-          <p:cNvPr id="8" name="Shape 6"/>
-          <p:cNvSpPr/>
-          <p:nvPr/>
-        </p:nvSpPr>
-        <p:spPr>
-          <a:xfrm>
-            <a:off x="4754880" y="1005840"/>
-            <a:ext cx="54864" cy="1188720"/>
-          </a:xfrm>
-          <a:prstGeom prst="rect">
-            <a:avLst/>
-          </a:prstGeom>
-          <a:solidFill>
-            <a:srgbClr val="718096"/>
-          </a:solidFill>
-          <a:ln/>
-        </p:spPr>
-      </p:sp>
-      <p:sp>
-        <p:nvSpPr>
-          <p:cNvPr id="9" name="Text 7"/>
-          <p:cNvSpPr/>
-          <p:nvPr/>
-        </p:nvSpPr>
-        <p:spPr>
-          <a:xfrm>
-            <a:off x="4937760" y="1097280"/>
-            <a:ext cx="3566160" cy="365760"/>
+            <a:endParaRPr lang="en-US" sz="1400" dirty="0"/>
+          </a:p>
+        </p:txBody>
+      </p:sp>
+      <p:sp>
+        <p:nvSpPr>
+          <p:cNvPr id="6" name="Text 4"/>
+          <p:cNvSpPr/>
+          <p:nvPr/>
+        </p:nvSpPr>
+        <p:spPr>
+          <a:xfrm>
+            <a:off x="1371600" y="1645920"/>
+            <a:ext cx="6400800" cy="548640"/>
           </a:xfrm>
           <a:prstGeom prst="rect">
             <a:avLst/>
@@ -3440,41 +3945,16 @@
               <a:buNone/>
             </a:pPr>
             <a:r>
-              <a:rPr lang="en-US" sz="1600" b="1" dirty="0">
-                <a:solidFill>
-                  <a:srgbClr val="2D3748"/>
-                </a:solidFill>
-                <a:latin typeface="Arial" pitchFamily="34" charset="0"/>
-                <a:ea typeface="Arial" pitchFamily="34" charset="-122"/>
-                <a:cs typeface="Arial" pitchFamily="34" charset="-120"/>
-              </a:rPr>
-              <a:t>Stap 2: Oplossen</a:t>
-            </a:r>
-            <a:endParaRPr lang="en-US" sz="1600" dirty="0"/>
-          </a:p>
-        </p:txBody>
-      </p:sp>
-      <p:sp>
-        <p:nvSpPr>
-          <p:cNvPr id="10" name="Text 8"/>
-          <p:cNvSpPr/>
-          <p:nvPr/>
-        </p:nvSpPr>
-        <p:spPr>
-          <a:xfrm>
-            <a:off x="4937760" y="1508760"/>
-            <a:ext cx="3566160" cy="548640"/>
-          </a:xfrm>
-          <a:prstGeom prst="rect">
-            <a:avLst/>
-          </a:prstGeom>
-          <a:noFill/>
-          <a:ln/>
-        </p:spPr>
-        <p:txBody>
-          <a:bodyPr wrap="square" rtlCol="0" anchor="ctr"/>
-          <a:lstStyle/>
-          <a:p>
+              <a:rPr lang="en-US" sz="1400" b="1" dirty="0">
+                <a:solidFill>
+                  <a:srgbClr val="718096"/>
+                </a:solidFill>
+                <a:latin typeface="Arial" pitchFamily="34" charset="0"/>
+                <a:ea typeface="Arial" pitchFamily="34" charset="-122"/>
+                <a:cs typeface="Arial" pitchFamily="34" charset="-120"/>
+              </a:rPr>
+              <a:t>Stap 2: Oplossen:  </a:t>
+            </a:r>
             <a:pPr indent="0" marL="0">
               <a:buNone/>
             </a:pPr>
@@ -3489,69 +3969,20 @@
               </a:rPr>
               <a:t>2,5Q = 50  →  Q* = 20</a:t>
             </a:r>
-            <a:endParaRPr lang="en-US" sz="1700" dirty="0"/>
-          </a:p>
-        </p:txBody>
-      </p:sp>
-      <p:sp>
-        <p:nvSpPr>
-          <p:cNvPr id="11" name="Shape 9"/>
-          <p:cNvSpPr/>
-          <p:nvPr/>
-        </p:nvSpPr>
-        <p:spPr>
-          <a:xfrm>
-            <a:off x="457200" y="2468880"/>
-            <a:ext cx="3931920" cy="1188720"/>
-          </a:xfrm>
-          <a:prstGeom prst="rect">
-            <a:avLst>
-              <a:gd name="adj" fmla="val 3846"/>
-            </a:avLst>
-          </a:prstGeom>
-          <a:solidFill>
-            <a:srgbClr val="EBF5FB"/>
-          </a:solidFill>
-          <a:ln/>
-          <a:effectLst>
-            <a:outerShdw sx="100000" sy="100000" kx="0" ky="0" algn="bl" rotWithShape="0" blurRad="76200" dist="25400" dir="8100000">
-              <a:srgbClr val="000000">
-                <a:alpha val="10000"/>
-              </a:srgbClr>
-            </a:outerShdw>
-          </a:effectLst>
-        </p:spPr>
-      </p:sp>
-      <p:sp>
-        <p:nvSpPr>
-          <p:cNvPr id="12" name="Shape 10"/>
-          <p:cNvSpPr/>
-          <p:nvPr/>
-        </p:nvSpPr>
-        <p:spPr>
-          <a:xfrm>
-            <a:off x="457200" y="2468880"/>
-            <a:ext cx="54864" cy="1188720"/>
-          </a:xfrm>
-          <a:prstGeom prst="rect">
-            <a:avLst/>
-          </a:prstGeom>
-          <a:solidFill>
-            <a:srgbClr val="1A5276"/>
-          </a:solidFill>
-          <a:ln/>
-        </p:spPr>
-      </p:sp>
-      <p:sp>
-        <p:nvSpPr>
-          <p:cNvPr id="13" name="Text 11"/>
-          <p:cNvSpPr/>
-          <p:nvPr/>
-        </p:nvSpPr>
-        <p:spPr>
-          <a:xfrm>
-            <a:off x="640080" y="2560320"/>
-            <a:ext cx="3566160" cy="365760"/>
+            <a:endParaRPr lang="en-US" sz="1400" dirty="0"/>
+          </a:p>
+        </p:txBody>
+      </p:sp>
+      <p:sp>
+        <p:nvSpPr>
+          <p:cNvPr id="7" name="Text 5"/>
+          <p:cNvSpPr/>
+          <p:nvPr/>
+        </p:nvSpPr>
+        <p:spPr>
+          <a:xfrm>
+            <a:off x="1371600" y="2194560"/>
+            <a:ext cx="6400800" cy="548640"/>
           </a:xfrm>
           <a:prstGeom prst="rect">
             <a:avLst/>
@@ -3567,41 +3998,16 @@
               <a:buNone/>
             </a:pPr>
             <a:r>
-              <a:rPr lang="en-US" sz="1600" b="1" dirty="0">
-                <a:solidFill>
-                  <a:srgbClr val="1A5276"/>
-                </a:solidFill>
-                <a:latin typeface="Arial" pitchFamily="34" charset="0"/>
-                <a:ea typeface="Arial" pitchFamily="34" charset="-122"/>
-                <a:cs typeface="Arial" pitchFamily="34" charset="-120"/>
-              </a:rPr>
-              <a:t>Stap 3: Prijs</a:t>
-            </a:r>
-            <a:endParaRPr lang="en-US" sz="1600" dirty="0"/>
-          </a:p>
-        </p:txBody>
-      </p:sp>
-      <p:sp>
-        <p:nvSpPr>
-          <p:cNvPr id="14" name="Text 12"/>
-          <p:cNvSpPr/>
-          <p:nvPr/>
-        </p:nvSpPr>
-        <p:spPr>
-          <a:xfrm>
-            <a:off x="640080" y="2971800"/>
-            <a:ext cx="3566160" cy="548640"/>
-          </a:xfrm>
-          <a:prstGeom prst="rect">
-            <a:avLst/>
-          </a:prstGeom>
-          <a:noFill/>
-          <a:ln/>
-        </p:spPr>
-        <p:txBody>
-          <a:bodyPr wrap="square" rtlCol="0" anchor="ctr"/>
-          <a:lstStyle/>
-          <a:p>
+              <a:rPr lang="en-US" sz="1400" b="1" dirty="0">
+                <a:solidFill>
+                  <a:srgbClr val="718096"/>
+                </a:solidFill>
+                <a:latin typeface="Arial" pitchFamily="34" charset="0"/>
+                <a:ea typeface="Arial" pitchFamily="34" charset="-122"/>
+                <a:cs typeface="Arial" pitchFamily="34" charset="-120"/>
+              </a:rPr>
+              <a:t>Stap 3: Prijs:  </a:t>
+            </a:r>
             <a:pPr indent="0" marL="0">
               <a:buNone/>
             </a:pPr>
@@ -3616,69 +4022,20 @@
               </a:rPr>
               <a:t>p* = −20 + 50 = €30</a:t>
             </a:r>
-            <a:endParaRPr lang="en-US" sz="1700" dirty="0"/>
-          </a:p>
-        </p:txBody>
-      </p:sp>
-      <p:sp>
-        <p:nvSpPr>
-          <p:cNvPr id="15" name="Shape 13"/>
-          <p:cNvSpPr/>
-          <p:nvPr/>
-        </p:nvSpPr>
-        <p:spPr>
-          <a:xfrm>
-            <a:off x="4754880" y="2468880"/>
-            <a:ext cx="3931920" cy="1188720"/>
-          </a:xfrm>
-          <a:prstGeom prst="rect">
-            <a:avLst>
-              <a:gd name="adj" fmla="val 3846"/>
-            </a:avLst>
-          </a:prstGeom>
-          <a:solidFill>
-            <a:srgbClr val="EBF5FB"/>
-          </a:solidFill>
-          <a:ln/>
-          <a:effectLst>
-            <a:outerShdw sx="100000" sy="100000" kx="0" ky="0" algn="bl" rotWithShape="0" blurRad="76200" dist="25400" dir="8100000">
-              <a:srgbClr val="000000">
-                <a:alpha val="10000"/>
-              </a:srgbClr>
-            </a:outerShdw>
-          </a:effectLst>
-        </p:spPr>
-      </p:sp>
-      <p:sp>
-        <p:nvSpPr>
-          <p:cNvPr id="16" name="Shape 14"/>
-          <p:cNvSpPr/>
-          <p:nvPr/>
-        </p:nvSpPr>
-        <p:spPr>
-          <a:xfrm>
-            <a:off x="4754880" y="2468880"/>
-            <a:ext cx="54864" cy="1188720"/>
-          </a:xfrm>
-          <a:prstGeom prst="rect">
-            <a:avLst/>
-          </a:prstGeom>
-          <a:solidFill>
-            <a:srgbClr val="1A5276"/>
-          </a:solidFill>
-          <a:ln/>
-        </p:spPr>
-      </p:sp>
-      <p:sp>
-        <p:nvSpPr>
-          <p:cNvPr id="17" name="Text 15"/>
-          <p:cNvSpPr/>
-          <p:nvPr/>
-        </p:nvSpPr>
-        <p:spPr>
-          <a:xfrm>
-            <a:off x="4937760" y="2560320"/>
-            <a:ext cx="3566160" cy="365760"/>
+            <a:endParaRPr lang="en-US" sz="1400" dirty="0"/>
+          </a:p>
+        </p:txBody>
+      </p:sp>
+      <p:sp>
+        <p:nvSpPr>
+          <p:cNvPr id="8" name="Text 6"/>
+          <p:cNvSpPr/>
+          <p:nvPr/>
+        </p:nvSpPr>
+        <p:spPr>
+          <a:xfrm>
+            <a:off x="1371600" y="2743200"/>
+            <a:ext cx="6400800" cy="548640"/>
           </a:xfrm>
           <a:prstGeom prst="rect">
             <a:avLst/>
@@ -3694,41 +4051,16 @@
               <a:buNone/>
             </a:pPr>
             <a:r>
-              <a:rPr lang="en-US" sz="1600" b="1" dirty="0">
-                <a:solidFill>
-                  <a:srgbClr val="1A5276"/>
-                </a:solidFill>
-                <a:latin typeface="Arial" pitchFamily="34" charset="0"/>
-                <a:ea typeface="Arial" pitchFamily="34" charset="-122"/>
-                <a:cs typeface="Arial" pitchFamily="34" charset="-120"/>
-              </a:rPr>
-              <a:t>Stap 4: Winst</a:t>
-            </a:r>
-            <a:endParaRPr lang="en-US" sz="1600" dirty="0"/>
-          </a:p>
-        </p:txBody>
-      </p:sp>
-      <p:sp>
-        <p:nvSpPr>
-          <p:cNvPr id="18" name="Text 16"/>
-          <p:cNvSpPr/>
-          <p:nvPr/>
-        </p:nvSpPr>
-        <p:spPr>
-          <a:xfrm>
-            <a:off x="4937760" y="2971800"/>
-            <a:ext cx="3566160" cy="548640"/>
-          </a:xfrm>
-          <a:prstGeom prst="rect">
-            <a:avLst/>
-          </a:prstGeom>
-          <a:noFill/>
-          <a:ln/>
-        </p:spPr>
-        <p:txBody>
-          <a:bodyPr wrap="square" rtlCol="0" anchor="ctr"/>
-          <a:lstStyle/>
-          <a:p>
+              <a:rPr lang="en-US" sz="1400" b="1" dirty="0">
+                <a:solidFill>
+                  <a:srgbClr val="718096"/>
+                </a:solidFill>
+                <a:latin typeface="Arial" pitchFamily="34" charset="0"/>
+                <a:ea typeface="Arial" pitchFamily="34" charset="-122"/>
+                <a:cs typeface="Arial" pitchFamily="34" charset="-120"/>
+              </a:rPr>
+              <a:t>Stap 4: Winst:  </a:t>
+            </a:r>
             <a:pPr indent="0" marL="0">
               <a:buNone/>
             </a:pPr>
@@ -3743,24 +4075,24 @@
               </a:rPr>
               <a:t>(30 − 5) × 20 = €500</a:t>
             </a:r>
-            <a:endParaRPr lang="en-US" sz="1700" dirty="0"/>
-          </a:p>
-        </p:txBody>
-      </p:sp>
-      <p:sp>
-        <p:nvSpPr>
-          <p:cNvPr id="19" name="Shape 17"/>
-          <p:cNvSpPr/>
-          <p:nvPr/>
-        </p:nvSpPr>
-        <p:spPr>
-          <a:xfrm>
-            <a:off x="457200" y="3931920"/>
-            <a:ext cx="8229600" cy="594360"/>
+            <a:endParaRPr lang="en-US" sz="1400" dirty="0"/>
+          </a:p>
+        </p:txBody>
+      </p:sp>
+      <p:sp>
+        <p:nvSpPr>
+          <p:cNvPr id="9" name="Shape 7"/>
+          <p:cNvSpPr/>
+          <p:nvPr/>
+        </p:nvSpPr>
+        <p:spPr>
+          <a:xfrm>
+            <a:off x="1143000" y="3520440"/>
+            <a:ext cx="6858000" cy="502920"/>
           </a:xfrm>
           <a:prstGeom prst="rect">
             <a:avLst>
-              <a:gd name="adj" fmla="val 7692"/>
+              <a:gd name="adj" fmla="val 9091"/>
             </a:avLst>
           </a:prstGeom>
           <a:solidFill>
@@ -3771,14 +4103,14 @@
       </p:sp>
       <p:sp>
         <p:nvSpPr>
-          <p:cNvPr id="20" name="Shape 18"/>
-          <p:cNvSpPr/>
-          <p:nvPr/>
-        </p:nvSpPr>
-        <p:spPr>
-          <a:xfrm>
-            <a:off x="457200" y="3931920"/>
-            <a:ext cx="54864" cy="594360"/>
+          <p:cNvPr id="10" name="Shape 8"/>
+          <p:cNvSpPr/>
+          <p:nvPr/>
+        </p:nvSpPr>
+        <p:spPr>
+          <a:xfrm>
+            <a:off x="1143000" y="3520440"/>
+            <a:ext cx="54864" cy="502920"/>
           </a:xfrm>
           <a:prstGeom prst="rect">
             <a:avLst/>
@@ -3791,14 +4123,14 @@
       </p:sp>
       <p:sp>
         <p:nvSpPr>
-          <p:cNvPr id="21" name="Text 19"/>
-          <p:cNvSpPr/>
-          <p:nvPr/>
-        </p:nvSpPr>
-        <p:spPr>
-          <a:xfrm>
-            <a:off x="658368" y="3931920"/>
-            <a:ext cx="7772400" cy="594360"/>
+          <p:cNvPr id="11" name="Text 9"/>
+          <p:cNvSpPr/>
+          <p:nvPr/>
+        </p:nvSpPr>
+        <p:spPr>
+          <a:xfrm>
+            <a:off x="1371600" y="3520440"/>
+            <a:ext cx="6400800" cy="502920"/>
           </a:xfrm>
           <a:prstGeom prst="rect">
             <a:avLst/>
@@ -3886,380 +4218,36 @@
                 <a:ea typeface="Arial" pitchFamily="34" charset="-122"/>
                 <a:cs typeface="Arial" pitchFamily="34" charset="-120"/>
               </a:rPr>
-              <a:t>Winst en CS berekenen</a:t>
+              <a:t>Monopolie: winstmaximalisatie in de grafiek</a:t>
             </a:r>
             <a:endParaRPr lang="en-US" sz="2400" dirty="0"/>
           </a:p>
         </p:txBody>
       </p:sp>
-      <p:sp>
-        <p:nvSpPr>
-          <p:cNvPr id="3" name="Shape 1"/>
-          <p:cNvSpPr/>
-          <p:nvPr/>
-        </p:nvSpPr>
-        <p:spPr>
-          <a:xfrm>
-            <a:off x="457200" y="1005840"/>
-            <a:ext cx="3931920" cy="3017520"/>
-          </a:xfrm>
-          <a:prstGeom prst="rect">
-            <a:avLst>
-              <a:gd name="adj" fmla="val 1515"/>
-            </a:avLst>
-          </a:prstGeom>
-          <a:solidFill>
-            <a:srgbClr val="F9F6F1"/>
-          </a:solidFill>
-          <a:ln/>
-          <a:effectLst>
-            <a:outerShdw sx="100000" sy="100000" kx="0" ky="0" algn="bl" rotWithShape="0" blurRad="76200" dist="25400" dir="8100000">
-              <a:srgbClr val="000000">
-                <a:alpha val="10000"/>
-              </a:srgbClr>
-            </a:outerShdw>
-          </a:effectLst>
-        </p:spPr>
-      </p:sp>
-      <p:sp>
-        <p:nvSpPr>
-          <p:cNvPr id="4" name="Shape 2"/>
-          <p:cNvSpPr/>
-          <p:nvPr/>
-        </p:nvSpPr>
-        <p:spPr>
-          <a:xfrm>
-            <a:off x="457200" y="1005840"/>
-            <a:ext cx="54864" cy="3017520"/>
-          </a:xfrm>
-          <a:prstGeom prst="rect">
-            <a:avLst/>
-          </a:prstGeom>
-          <a:solidFill>
-            <a:srgbClr val="1A5276"/>
-          </a:solidFill>
-          <a:ln/>
-        </p:spPr>
-      </p:sp>
-      <p:sp>
-        <p:nvSpPr>
-          <p:cNvPr id="5" name="Text 3"/>
-          <p:cNvSpPr/>
-          <p:nvPr/>
-        </p:nvSpPr>
-        <p:spPr>
-          <a:xfrm>
-            <a:off x="640080" y="1143000"/>
-            <a:ext cx="3611880" cy="365760"/>
-          </a:xfrm>
-          <a:prstGeom prst="rect">
-            <a:avLst/>
-          </a:prstGeom>
-          <a:noFill/>
-          <a:ln/>
-        </p:spPr>
-        <p:txBody>
-          <a:bodyPr wrap="square" rtlCol="0" anchor="t"/>
-          <a:lstStyle/>
-          <a:p>
-            <a:pPr indent="0" marL="0">
-              <a:buNone/>
-            </a:pPr>
-            <a:r>
-              <a:rPr lang="en-US" sz="2000" b="1" dirty="0">
-                <a:solidFill>
-                  <a:srgbClr val="1A5276"/>
-                </a:solidFill>
-                <a:latin typeface="Arial" pitchFamily="34" charset="0"/>
-                <a:ea typeface="Arial" pitchFamily="34" charset="-122"/>
-                <a:cs typeface="Arial" pitchFamily="34" charset="-120"/>
-              </a:rPr>
-              <a:t>Maximale winst</a:t>
-            </a:r>
-            <a:endParaRPr lang="en-US" sz="2000" dirty="0"/>
-          </a:p>
-        </p:txBody>
-      </p:sp>
-      <p:sp>
-        <p:nvSpPr>
-          <p:cNvPr id="6" name="Text 4"/>
-          <p:cNvSpPr/>
-          <p:nvPr/>
-        </p:nvSpPr>
-        <p:spPr>
-          <a:xfrm>
-            <a:off x="640080" y="1554480"/>
-            <a:ext cx="3611880" cy="2331720"/>
-          </a:xfrm>
-          <a:prstGeom prst="rect">
-            <a:avLst/>
-          </a:prstGeom>
-          <a:noFill/>
-          <a:ln/>
-        </p:spPr>
-        <p:txBody>
-          <a:bodyPr wrap="square" rtlCol="0" anchor="t"/>
-          <a:lstStyle/>
-          <a:p>
-            <a:pPr algn="l" indent="0" marL="0">
-              <a:lnSpc>
-                <a:spcPct val="115000"/>
-              </a:lnSpc>
-              <a:buNone/>
-            </a:pPr>
-            <a:r>
-              <a:rPr lang="en-US" sz="1500" b="1" dirty="0">
-                <a:solidFill>
-                  <a:srgbClr val="2D3748"/>
-                </a:solidFill>
-                <a:latin typeface="Arial" pitchFamily="34" charset="0"/>
-                <a:ea typeface="Arial" pitchFamily="34" charset="-122"/>
-                <a:cs typeface="Arial" pitchFamily="34" charset="-120"/>
-              </a:rPr>
-              <a:t>W = TO − TK
-</a:t>
-            </a:r>
-            <a:pPr algn="l" indent="0" marL="0">
-              <a:lnSpc>
-                <a:spcPct val="115000"/>
-              </a:lnSpc>
-              <a:buNone/>
-            </a:pPr>
-            <a:r>
-              <a:rPr lang="en-US" sz="1400" dirty="0">
-                <a:solidFill>
-                  <a:srgbClr val="2D3748"/>
-                </a:solidFill>
-                <a:latin typeface="Consolas" pitchFamily="34" charset="0"/>
-                <a:ea typeface="Consolas" pitchFamily="34" charset="-122"/>
-                <a:cs typeface="Consolas" pitchFamily="34" charset="-120"/>
-              </a:rPr>
-              <a:t>TO = 30 × 20 = €600
-</a:t>
-            </a:r>
-            <a:pPr algn="l" indent="0" marL="0">
-              <a:lnSpc>
-                <a:spcPct val="115000"/>
-              </a:lnSpc>
-              <a:buNone/>
-            </a:pPr>
-            <a:r>
-              <a:rPr lang="en-US" sz="1400" dirty="0">
-                <a:solidFill>
-                  <a:srgbClr val="2D3748"/>
-                </a:solidFill>
-                <a:latin typeface="Consolas" pitchFamily="34" charset="0"/>
-                <a:ea typeface="Consolas" pitchFamily="34" charset="-122"/>
-                <a:cs typeface="Consolas" pitchFamily="34" charset="-120"/>
-              </a:rPr>
-              <a:t>TK = 0,25 × 400 = €100
-</a:t>
-            </a:r>
-            <a:pPr algn="l" indent="0" marL="0">
-              <a:lnSpc>
-                <a:spcPct val="115000"/>
-              </a:lnSpc>
-              <a:buNone/>
-            </a:pPr>
-            <a:r>
-              <a:rPr lang="en-US" sz="1800" b="1" dirty="0">
-                <a:solidFill>
-                  <a:srgbClr val="1A5276"/>
-                </a:solidFill>
-                <a:latin typeface="Consolas" pitchFamily="34" charset="0"/>
-                <a:ea typeface="Consolas" pitchFamily="34" charset="-122"/>
-                <a:cs typeface="Consolas" pitchFamily="34" charset="-120"/>
-              </a:rPr>
-              <a:t>W = €500</a:t>
-            </a:r>
-            <a:endParaRPr lang="en-US" sz="1400" dirty="0"/>
-          </a:p>
-        </p:txBody>
-      </p:sp>
-      <p:sp>
-        <p:nvSpPr>
-          <p:cNvPr id="7" name="Shape 5"/>
-          <p:cNvSpPr/>
-          <p:nvPr/>
-        </p:nvSpPr>
-        <p:spPr>
-          <a:xfrm>
-            <a:off x="4754880" y="1005840"/>
-            <a:ext cx="3931920" cy="3017520"/>
-          </a:xfrm>
-          <a:prstGeom prst="rect">
-            <a:avLst>
-              <a:gd name="adj" fmla="val 1515"/>
-            </a:avLst>
-          </a:prstGeom>
-          <a:solidFill>
-            <a:srgbClr val="F9F6F1"/>
-          </a:solidFill>
-          <a:ln/>
-          <a:effectLst>
-            <a:outerShdw sx="100000" sy="100000" kx="0" ky="0" algn="bl" rotWithShape="0" blurRad="76200" dist="25400" dir="8100000">
-              <a:srgbClr val="000000">
-                <a:alpha val="10000"/>
-              </a:srgbClr>
-            </a:outerShdw>
-          </a:effectLst>
-        </p:spPr>
-      </p:sp>
-      <p:sp>
-        <p:nvSpPr>
-          <p:cNvPr id="8" name="Shape 6"/>
-          <p:cNvSpPr/>
-          <p:nvPr/>
-        </p:nvSpPr>
-        <p:spPr>
-          <a:xfrm>
-            <a:off x="4754880" y="1005840"/>
-            <a:ext cx="54864" cy="3017520"/>
-          </a:xfrm>
-          <a:prstGeom prst="rect">
-            <a:avLst/>
-          </a:prstGeom>
-          <a:solidFill>
-            <a:srgbClr val="1E8449"/>
-          </a:solidFill>
-          <a:ln/>
-        </p:spPr>
-      </p:sp>
-      <p:sp>
-        <p:nvSpPr>
-          <p:cNvPr id="9" name="Text 7"/>
-          <p:cNvSpPr/>
-          <p:nvPr/>
-        </p:nvSpPr>
-        <p:spPr>
-          <a:xfrm>
-            <a:off x="4937760" y="1143000"/>
-            <a:ext cx="3611880" cy="365760"/>
-          </a:xfrm>
-          <a:prstGeom prst="rect">
-            <a:avLst/>
-          </a:prstGeom>
-          <a:noFill/>
-          <a:ln/>
-        </p:spPr>
-        <p:txBody>
-          <a:bodyPr wrap="square" rtlCol="0" anchor="t"/>
-          <a:lstStyle/>
-          <a:p>
-            <a:pPr indent="0" marL="0">
-              <a:buNone/>
-            </a:pPr>
-            <a:r>
-              <a:rPr lang="en-US" sz="2000" b="1" dirty="0">
-                <a:solidFill>
-                  <a:srgbClr val="1E8449"/>
-                </a:solidFill>
-                <a:latin typeface="Arial" pitchFamily="34" charset="0"/>
-                <a:ea typeface="Arial" pitchFamily="34" charset="-122"/>
-                <a:cs typeface="Arial" pitchFamily="34" charset="-120"/>
-              </a:rPr>
-              <a:t>Consumentensurplus</a:t>
-            </a:r>
-            <a:endParaRPr lang="en-US" sz="2000" dirty="0"/>
-          </a:p>
-        </p:txBody>
-      </p:sp>
-      <p:sp>
-        <p:nvSpPr>
-          <p:cNvPr id="10" name="Text 8"/>
-          <p:cNvSpPr/>
-          <p:nvPr/>
-        </p:nvSpPr>
-        <p:spPr>
-          <a:xfrm>
-            <a:off x="4937760" y="1554480"/>
-            <a:ext cx="3611880" cy="2331720"/>
-          </a:xfrm>
-          <a:prstGeom prst="rect">
-            <a:avLst/>
-          </a:prstGeom>
-          <a:noFill/>
-          <a:ln/>
-        </p:spPr>
-        <p:txBody>
-          <a:bodyPr wrap="square" rtlCol="0" anchor="t"/>
-          <a:lstStyle/>
-          <a:p>
-            <a:pPr algn="l" indent="0" marL="0">
-              <a:lnSpc>
-                <a:spcPct val="115000"/>
-              </a:lnSpc>
-              <a:buNone/>
-            </a:pPr>
-            <a:r>
-              <a:rPr lang="en-US" sz="1500" b="1" dirty="0">
-                <a:solidFill>
-                  <a:srgbClr val="2D3748"/>
-                </a:solidFill>
-                <a:latin typeface="Arial" pitchFamily="34" charset="0"/>
-                <a:ea typeface="Arial" pitchFamily="34" charset="-122"/>
-                <a:cs typeface="Arial" pitchFamily="34" charset="-120"/>
-              </a:rPr>
-              <a:t>CS = ½ × Q* × (p_max − p*)
-</a:t>
-            </a:r>
-            <a:pPr algn="l" indent="0" marL="0">
-              <a:lnSpc>
-                <a:spcPct val="115000"/>
-              </a:lnSpc>
-              <a:buNone/>
-            </a:pPr>
-            <a:r>
-              <a:rPr lang="en-US" sz="1400" dirty="0">
-                <a:solidFill>
-                  <a:srgbClr val="2D3748"/>
-                </a:solidFill>
-                <a:latin typeface="Consolas" pitchFamily="34" charset="0"/>
-                <a:ea typeface="Consolas" pitchFamily="34" charset="-122"/>
-                <a:cs typeface="Consolas" pitchFamily="34" charset="-120"/>
-              </a:rPr>
-              <a:t>CS = ½ × 20 × (50 − 30)
-</a:t>
-            </a:r>
-            <a:pPr algn="l" indent="0" marL="0">
-              <a:lnSpc>
-                <a:spcPct val="115000"/>
-              </a:lnSpc>
-              <a:buNone/>
-            </a:pPr>
-            <a:r>
-              <a:rPr lang="en-US" sz="1400" dirty="0">
-                <a:solidFill>
-                  <a:srgbClr val="2D3748"/>
-                </a:solidFill>
-                <a:latin typeface="Consolas" pitchFamily="34" charset="0"/>
-                <a:ea typeface="Consolas" pitchFamily="34" charset="-122"/>
-                <a:cs typeface="Consolas" pitchFamily="34" charset="-120"/>
-              </a:rPr>
-              <a:t>CS = ½ × 20 × 20
-</a:t>
-            </a:r>
-            <a:pPr algn="l" indent="0" marL="0">
-              <a:lnSpc>
-                <a:spcPct val="115000"/>
-              </a:lnSpc>
-              <a:buNone/>
-            </a:pPr>
-            <a:r>
-              <a:rPr lang="en-US" sz="1800" b="1" dirty="0">
-                <a:solidFill>
-                  <a:srgbClr val="1E8449"/>
-                </a:solidFill>
-                <a:latin typeface="Consolas" pitchFamily="34" charset="0"/>
-                <a:ea typeface="Consolas" pitchFamily="34" charset="-122"/>
-                <a:cs typeface="Consolas" pitchFamily="34" charset="-120"/>
-              </a:rPr>
-              <a:t>CS = €200</a:t>
-            </a:r>
-            <a:endParaRPr lang="en-US" sz="1400" dirty="0"/>
-          </a:p>
-        </p:txBody>
-      </p:sp>
+      <p:pic>
+        <p:nvPicPr>
+          <p:cNvPr id="3" name="Image 0" descr="preencoded.png">    </p:cNvPr>
+          <p:cNvPicPr>
+            <a:picLocks noChangeAspect="1"/>
+          </p:cNvPicPr>
+          <p:nvPr/>
+        </p:nvPicPr>
+        <p:blipFill>
+          <a:blip r:embed="rId1"/>
+          <a:stretch>
+            <a:fillRect/>
+          </a:stretch>
+        </p:blipFill>
+        <p:spPr>
+          <a:xfrm>
+            <a:off x="685800" y="822960"/>
+            <a:ext cx="7772400" cy="3886200"/>
+          </a:xfrm>
+          <a:prstGeom prst="rect">
+            <a:avLst/>
+          </a:prstGeom>
+        </p:spPr>
+      </p:pic>
     </p:spTree>
   </p:cSld>
   <p:clrMapOvr>
@@ -4318,7 +4306,7 @@
                 <a:ea typeface="Arial" pitchFamily="34" charset="-122"/>
                 <a:cs typeface="Arial" pitchFamily="34" charset="-120"/>
               </a:rPr>
-              <a:t>Prijsdiscriminatie</a:t>
+              <a:t>Winst en CS berekenen</a:t>
             </a:r>
             <a:endParaRPr lang="en-US" sz="2400" dirty="0"/>
           </a:p>
@@ -4332,12 +4320,12 @@
         </p:nvSpPr>
         <p:spPr>
           <a:xfrm>
-            <a:off x="457200" y="914400"/>
-            <a:ext cx="8229600" cy="749808"/>
+            <a:off x="457200" y="1005840"/>
+            <a:ext cx="3931920" cy="3017520"/>
           </a:xfrm>
           <a:prstGeom prst="rect">
             <a:avLst>
-              <a:gd name="adj" fmla="val 6098"/>
+              <a:gd name="adj" fmla="val 1515"/>
             </a:avLst>
           </a:prstGeom>
           <a:solidFill>
@@ -4361,14 +4349,14 @@
         </p:nvSpPr>
         <p:spPr>
           <a:xfrm>
-            <a:off x="457200" y="914400"/>
-            <a:ext cx="54864" cy="749808"/>
+            <a:off x="457200" y="1005840"/>
+            <a:ext cx="54864" cy="3017520"/>
           </a:xfrm>
           <a:prstGeom prst="rect">
             <a:avLst/>
           </a:prstGeom>
           <a:solidFill>
-            <a:srgbClr val="1A5276"/>
+            <a:srgbClr val="1E8449"/>
           </a:solidFill>
           <a:ln/>
         </p:spPr>
@@ -4381,8 +4369,8 @@
         </p:nvSpPr>
         <p:spPr>
           <a:xfrm>
-            <a:off x="658368" y="960120"/>
-            <a:ext cx="7772400" cy="292608"/>
+            <a:off x="640080" y="1143000"/>
+            <a:ext cx="3611880" cy="365760"/>
           </a:xfrm>
           <a:prstGeom prst="rect">
             <a:avLst/>
@@ -4391,24 +4379,24 @@
           <a:ln/>
         </p:spPr>
         <p:txBody>
-          <a:bodyPr wrap="square" rtlCol="0" anchor="ctr"/>
+          <a:bodyPr wrap="square" rtlCol="0" anchor="t"/>
           <a:lstStyle/>
           <a:p>
             <a:pPr indent="0" marL="0">
               <a:buNone/>
             </a:pPr>
             <a:r>
-              <a:rPr lang="en-US" sz="1700" b="1" dirty="0">
-                <a:solidFill>
-                  <a:srgbClr val="1A5276"/>
-                </a:solidFill>
-                <a:latin typeface="Arial" pitchFamily="34" charset="0"/>
-                <a:ea typeface="Arial" pitchFamily="34" charset="-122"/>
-                <a:cs typeface="Arial" pitchFamily="34" charset="-120"/>
-              </a:rPr>
-              <a:t>Wat is het?</a:t>
-            </a:r>
-            <a:endParaRPr lang="en-US" sz="1700" dirty="0"/>
+              <a:rPr lang="en-US" sz="2000" b="1" dirty="0">
+                <a:solidFill>
+                  <a:srgbClr val="1E8449"/>
+                </a:solidFill>
+                <a:latin typeface="Arial" pitchFamily="34" charset="0"/>
+                <a:ea typeface="Arial" pitchFamily="34" charset="-122"/>
+                <a:cs typeface="Arial" pitchFamily="34" charset="-120"/>
+              </a:rPr>
+              <a:t>Maximale winst</a:t>
+            </a:r>
+            <a:endParaRPr lang="en-US" sz="2000" dirty="0"/>
           </a:p>
         </p:txBody>
       </p:sp>
@@ -4420,8 +4408,8 @@
         </p:nvSpPr>
         <p:spPr>
           <a:xfrm>
-            <a:off x="658368" y="1261872"/>
-            <a:ext cx="7772400" cy="347472"/>
+            <a:off x="640080" y="1554480"/>
+            <a:ext cx="3611880" cy="2331720"/>
           </a:xfrm>
           <a:prstGeom prst="rect">
             <a:avLst/>
@@ -4430,10 +4418,31 @@
           <a:ln/>
         </p:spPr>
         <p:txBody>
-          <a:bodyPr wrap="square" rtlCol="0" anchor="ctr"/>
-          <a:lstStyle/>
-          <a:p>
-            <a:pPr indent="0" marL="0">
+          <a:bodyPr wrap="square" rtlCol="0" anchor="t"/>
+          <a:lstStyle/>
+          <a:p>
+            <a:pPr algn="l" indent="0" marL="0">
+              <a:lnSpc>
+                <a:spcPct val="115000"/>
+              </a:lnSpc>
+              <a:buNone/>
+            </a:pPr>
+            <a:r>
+              <a:rPr lang="en-US" sz="1400" b="1" dirty="0">
+                <a:solidFill>
+                  <a:srgbClr val="2D3748"/>
+                </a:solidFill>
+                <a:latin typeface="Arial" pitchFamily="34" charset="0"/>
+                <a:ea typeface="Arial" pitchFamily="34" charset="-122"/>
+                <a:cs typeface="Arial" pitchFamily="34" charset="-120"/>
+              </a:rPr>
+              <a:t>W = TO − TK
+</a:t>
+            </a:r>
+            <a:pPr algn="l" indent="0" marL="0">
+              <a:lnSpc>
+                <a:spcPct val="115000"/>
+              </a:lnSpc>
               <a:buNone/>
             </a:pPr>
             <a:r>
@@ -4441,11 +4450,47 @@
                 <a:solidFill>
                   <a:srgbClr val="2D3748"/>
                 </a:solidFill>
-                <a:latin typeface="Arial" pitchFamily="34" charset="0"/>
-                <a:ea typeface="Arial" pitchFamily="34" charset="-122"/>
-                <a:cs typeface="Arial" pitchFamily="34" charset="-120"/>
-              </a:rPr>
-              <a:t>Verschillende prijzen vragen aan verschillende groepen voor hetzelfde product</a:t>
+                <a:latin typeface="Consolas" pitchFamily="34" charset="0"/>
+                <a:ea typeface="Consolas" pitchFamily="34" charset="-122"/>
+                <a:cs typeface="Consolas" pitchFamily="34" charset="-120"/>
+              </a:rPr>
+              <a:t>TO = 30 × 20 = €600
+</a:t>
+            </a:r>
+            <a:pPr algn="l" indent="0" marL="0">
+              <a:lnSpc>
+                <a:spcPct val="115000"/>
+              </a:lnSpc>
+              <a:buNone/>
+            </a:pPr>
+            <a:r>
+              <a:rPr lang="en-US" sz="1400" dirty="0">
+                <a:solidFill>
+                  <a:srgbClr val="2D3748"/>
+                </a:solidFill>
+                <a:latin typeface="Consolas" pitchFamily="34" charset="0"/>
+                <a:ea typeface="Consolas" pitchFamily="34" charset="-122"/>
+                <a:cs typeface="Consolas" pitchFamily="34" charset="-120"/>
+              </a:rPr>
+              <a:t>TK = 0,25 × 400 = €100
+</a:t>
+            </a:r>
+            <a:pPr algn="l" indent="0" marL="0">
+              <a:lnSpc>
+                <a:spcPct val="115000"/>
+              </a:lnSpc>
+              <a:buNone/>
+            </a:pPr>
+            <a:r>
+              <a:rPr lang="en-US" sz="1600" b="1" dirty="0">
+                <a:solidFill>
+                  <a:srgbClr val="2D3748"/>
+                </a:solidFill>
+                <a:latin typeface="Consolas" pitchFamily="34" charset="0"/>
+                <a:ea typeface="Consolas" pitchFamily="34" charset="-122"/>
+                <a:cs typeface="Consolas" pitchFamily="34" charset="-120"/>
+              </a:rPr>
+              <a:t>W = €500</a:t>
             </a:r>
             <a:endParaRPr lang="en-US" sz="1400" dirty="0"/>
           </a:p>
@@ -4459,12 +4504,12 @@
         </p:nvSpPr>
         <p:spPr>
           <a:xfrm>
-            <a:off x="457200" y="1828800"/>
-            <a:ext cx="8229600" cy="749808"/>
+            <a:off x="4754880" y="1005840"/>
+            <a:ext cx="3931920" cy="3017520"/>
           </a:xfrm>
           <a:prstGeom prst="rect">
             <a:avLst>
-              <a:gd name="adj" fmla="val 6098"/>
+              <a:gd name="adj" fmla="val 1515"/>
             </a:avLst>
           </a:prstGeom>
           <a:solidFill>
@@ -4488,8 +4533,8 @@
         </p:nvSpPr>
         <p:spPr>
           <a:xfrm>
-            <a:off x="457200" y="1828800"/>
-            <a:ext cx="54864" cy="749808"/>
+            <a:off x="4754880" y="1005840"/>
+            <a:ext cx="54864" cy="3017520"/>
           </a:xfrm>
           <a:prstGeom prst="rect">
             <a:avLst/>
@@ -4508,8 +4553,8 @@
         </p:nvSpPr>
         <p:spPr>
           <a:xfrm>
-            <a:off x="658368" y="1874520"/>
-            <a:ext cx="7772400" cy="292608"/>
+            <a:off x="4937760" y="1143000"/>
+            <a:ext cx="3611880" cy="365760"/>
           </a:xfrm>
           <a:prstGeom prst="rect">
             <a:avLst/>
@@ -4518,14 +4563,14 @@
           <a:ln/>
         </p:spPr>
         <p:txBody>
-          <a:bodyPr wrap="square" rtlCol="0" anchor="ctr"/>
+          <a:bodyPr wrap="square" rtlCol="0" anchor="t"/>
           <a:lstStyle/>
           <a:p>
             <a:pPr indent="0" marL="0">
               <a:buNone/>
             </a:pPr>
             <a:r>
-              <a:rPr lang="en-US" sz="1700" b="1" dirty="0">
+              <a:rPr lang="en-US" sz="2000" b="1" dirty="0">
                 <a:solidFill>
                   <a:srgbClr val="1A5276"/>
                 </a:solidFill>
@@ -4533,9 +4578,9 @@
                 <a:ea typeface="Arial" pitchFamily="34" charset="-122"/>
                 <a:cs typeface="Arial" pitchFamily="34" charset="-120"/>
               </a:rPr>
-              <a:t>Voorwaarde 1</a:t>
-            </a:r>
-            <a:endParaRPr lang="en-US" sz="1700" dirty="0"/>
+              <a:t>Consumentensurplus</a:t>
+            </a:r>
+            <a:endParaRPr lang="en-US" sz="2000" dirty="0"/>
           </a:p>
         </p:txBody>
       </p:sp>
@@ -4547,8 +4592,8 @@
         </p:nvSpPr>
         <p:spPr>
           <a:xfrm>
-            <a:off x="658368" y="2176272"/>
-            <a:ext cx="7772400" cy="347472"/>
+            <a:off x="4937760" y="1554480"/>
+            <a:ext cx="3611880" cy="2331720"/>
           </a:xfrm>
           <a:prstGeom prst="rect">
             <a:avLst/>
@@ -4557,10 +4602,31 @@
           <a:ln/>
         </p:spPr>
         <p:txBody>
-          <a:bodyPr wrap="square" rtlCol="0" anchor="ctr"/>
-          <a:lstStyle/>
-          <a:p>
-            <a:pPr indent="0" marL="0">
+          <a:bodyPr wrap="square" rtlCol="0" anchor="t"/>
+          <a:lstStyle/>
+          <a:p>
+            <a:pPr algn="l" indent="0" marL="0">
+              <a:lnSpc>
+                <a:spcPct val="115000"/>
+              </a:lnSpc>
+              <a:buNone/>
+            </a:pPr>
+            <a:r>
+              <a:rPr lang="en-US" sz="1400" b="1" dirty="0">
+                <a:solidFill>
+                  <a:srgbClr val="2D3748"/>
+                </a:solidFill>
+                <a:latin typeface="Arial" pitchFamily="34" charset="0"/>
+                <a:ea typeface="Arial" pitchFamily="34" charset="-122"/>
+                <a:cs typeface="Arial" pitchFamily="34" charset="-120"/>
+              </a:rPr>
+              <a:t>CS = ½ × Q* × (p_max − p*)
+</a:t>
+            </a:r>
+            <a:pPr algn="l" indent="0" marL="0">
+              <a:lnSpc>
+                <a:spcPct val="115000"/>
+              </a:lnSpc>
               <a:buNone/>
             </a:pPr>
             <a:r>
@@ -4568,126 +4634,17 @@
                 <a:solidFill>
                   <a:srgbClr val="2D3748"/>
                 </a:solidFill>
-                <a:latin typeface="Arial" pitchFamily="34" charset="0"/>
-                <a:ea typeface="Arial" pitchFamily="34" charset="-122"/>
-                <a:cs typeface="Arial" pitchFamily="34" charset="-120"/>
-              </a:rPr>
-              <a:t>Marktsegmenten zijn te onderscheiden (bijv. jongeren vs. ouderen)</a:t>
-            </a:r>
-            <a:endParaRPr lang="en-US" sz="1400" dirty="0"/>
-          </a:p>
-        </p:txBody>
-      </p:sp>
-      <p:sp>
-        <p:nvSpPr>
-          <p:cNvPr id="11" name="Shape 9"/>
-          <p:cNvSpPr/>
-          <p:nvPr/>
-        </p:nvSpPr>
-        <p:spPr>
-          <a:xfrm>
-            <a:off x="457200" y="2743200"/>
-            <a:ext cx="8229600" cy="749808"/>
-          </a:xfrm>
-          <a:prstGeom prst="rect">
-            <a:avLst>
-              <a:gd name="adj" fmla="val 6098"/>
-            </a:avLst>
-          </a:prstGeom>
-          <a:solidFill>
-            <a:srgbClr val="F9F6F1"/>
-          </a:solidFill>
-          <a:ln/>
-          <a:effectLst>
-            <a:outerShdw sx="100000" sy="100000" kx="0" ky="0" algn="bl" rotWithShape="0" blurRad="76200" dist="25400" dir="8100000">
-              <a:srgbClr val="000000">
-                <a:alpha val="10000"/>
-              </a:srgbClr>
-            </a:outerShdw>
-          </a:effectLst>
-        </p:spPr>
-      </p:sp>
-      <p:sp>
-        <p:nvSpPr>
-          <p:cNvPr id="12" name="Shape 10"/>
-          <p:cNvSpPr/>
-          <p:nvPr/>
-        </p:nvSpPr>
-        <p:spPr>
-          <a:xfrm>
-            <a:off x="457200" y="2743200"/>
-            <a:ext cx="54864" cy="749808"/>
-          </a:xfrm>
-          <a:prstGeom prst="rect">
-            <a:avLst/>
-          </a:prstGeom>
-          <a:solidFill>
-            <a:srgbClr val="1A5276"/>
-          </a:solidFill>
-          <a:ln/>
-        </p:spPr>
-      </p:sp>
-      <p:sp>
-        <p:nvSpPr>
-          <p:cNvPr id="13" name="Text 11"/>
-          <p:cNvSpPr/>
-          <p:nvPr/>
-        </p:nvSpPr>
-        <p:spPr>
-          <a:xfrm>
-            <a:off x="658368" y="2788920"/>
-            <a:ext cx="7772400" cy="292608"/>
-          </a:xfrm>
-          <a:prstGeom prst="rect">
-            <a:avLst/>
-          </a:prstGeom>
-          <a:noFill/>
-          <a:ln/>
-        </p:spPr>
-        <p:txBody>
-          <a:bodyPr wrap="square" rtlCol="0" anchor="ctr"/>
-          <a:lstStyle/>
-          <a:p>
-            <a:pPr indent="0" marL="0">
-              <a:buNone/>
-            </a:pPr>
-            <a:r>
-              <a:rPr lang="en-US" sz="1700" b="1" dirty="0">
-                <a:solidFill>
-                  <a:srgbClr val="1A5276"/>
-                </a:solidFill>
-                <a:latin typeface="Arial" pitchFamily="34" charset="0"/>
-                <a:ea typeface="Arial" pitchFamily="34" charset="-122"/>
-                <a:cs typeface="Arial" pitchFamily="34" charset="-120"/>
-              </a:rPr>
-              <a:t>Voorwaarde 2</a:t>
-            </a:r>
-            <a:endParaRPr lang="en-US" sz="1700" dirty="0"/>
-          </a:p>
-        </p:txBody>
-      </p:sp>
-      <p:sp>
-        <p:nvSpPr>
-          <p:cNvPr id="14" name="Text 12"/>
-          <p:cNvSpPr/>
-          <p:nvPr/>
-        </p:nvSpPr>
-        <p:spPr>
-          <a:xfrm>
-            <a:off x="658368" y="3090672"/>
-            <a:ext cx="7772400" cy="347472"/>
-          </a:xfrm>
-          <a:prstGeom prst="rect">
-            <a:avLst/>
-          </a:prstGeom>
-          <a:noFill/>
-          <a:ln/>
-        </p:spPr>
-        <p:txBody>
-          <a:bodyPr wrap="square" rtlCol="0" anchor="ctr"/>
-          <a:lstStyle/>
-          <a:p>
-            <a:pPr indent="0" marL="0">
+                <a:latin typeface="Consolas" pitchFamily="34" charset="0"/>
+                <a:ea typeface="Consolas" pitchFamily="34" charset="-122"/>
+                <a:cs typeface="Consolas" pitchFamily="34" charset="-120"/>
+              </a:rPr>
+              <a:t>CS = ½ × 20 × (50 − 30)
+</a:t>
+            </a:r>
+            <a:pPr algn="l" indent="0" marL="0">
+              <a:lnSpc>
+                <a:spcPct val="115000"/>
+              </a:lnSpc>
               <a:buNone/>
             </a:pPr>
             <a:r>
@@ -4695,138 +4652,29 @@
                 <a:solidFill>
                   <a:srgbClr val="2D3748"/>
                 </a:solidFill>
-                <a:latin typeface="Arial" pitchFamily="34" charset="0"/>
-                <a:ea typeface="Arial" pitchFamily="34" charset="-122"/>
-                <a:cs typeface="Arial" pitchFamily="34" charset="-120"/>
-              </a:rPr>
-              <a:t>Doorverkoop is niet mogelijk (kaart op naam, digitaal product)</a:t>
-            </a:r>
-            <a:endParaRPr lang="en-US" sz="1400" dirty="0"/>
-          </a:p>
-        </p:txBody>
-      </p:sp>
-      <p:sp>
-        <p:nvSpPr>
-          <p:cNvPr id="15" name="Shape 13"/>
-          <p:cNvSpPr/>
-          <p:nvPr/>
-        </p:nvSpPr>
-        <p:spPr>
-          <a:xfrm>
-            <a:off x="457200" y="3657600"/>
-            <a:ext cx="8229600" cy="749808"/>
-          </a:xfrm>
-          <a:prstGeom prst="rect">
-            <a:avLst>
-              <a:gd name="adj" fmla="val 6098"/>
-            </a:avLst>
-          </a:prstGeom>
-          <a:solidFill>
-            <a:srgbClr val="E8F8F0"/>
-          </a:solidFill>
-          <a:ln/>
-          <a:effectLst>
-            <a:outerShdw sx="100000" sy="100000" kx="0" ky="0" algn="bl" rotWithShape="0" blurRad="76200" dist="25400" dir="8100000">
-              <a:srgbClr val="000000">
-                <a:alpha val="10000"/>
-              </a:srgbClr>
-            </a:outerShdw>
-          </a:effectLst>
-        </p:spPr>
-      </p:sp>
-      <p:sp>
-        <p:nvSpPr>
-          <p:cNvPr id="16" name="Shape 14"/>
-          <p:cNvSpPr/>
-          <p:nvPr/>
-        </p:nvSpPr>
-        <p:spPr>
-          <a:xfrm>
-            <a:off x="457200" y="3657600"/>
-            <a:ext cx="54864" cy="749808"/>
-          </a:xfrm>
-          <a:prstGeom prst="rect">
-            <a:avLst/>
-          </a:prstGeom>
-          <a:solidFill>
-            <a:srgbClr val="1E8449"/>
-          </a:solidFill>
-          <a:ln/>
-        </p:spPr>
-      </p:sp>
-      <p:sp>
-        <p:nvSpPr>
-          <p:cNvPr id="17" name="Text 15"/>
-          <p:cNvSpPr/>
-          <p:nvPr/>
-        </p:nvSpPr>
-        <p:spPr>
-          <a:xfrm>
-            <a:off x="658368" y="3703320"/>
-            <a:ext cx="7772400" cy="292608"/>
-          </a:xfrm>
-          <a:prstGeom prst="rect">
-            <a:avLst/>
-          </a:prstGeom>
-          <a:noFill/>
-          <a:ln/>
-        </p:spPr>
-        <p:txBody>
-          <a:bodyPr wrap="square" rtlCol="0" anchor="ctr"/>
-          <a:lstStyle/>
-          <a:p>
-            <a:pPr indent="0" marL="0">
-              <a:buNone/>
-            </a:pPr>
-            <a:r>
-              <a:rPr lang="en-US" sz="1700" b="1" dirty="0">
-                <a:solidFill>
-                  <a:srgbClr val="1E8449"/>
-                </a:solidFill>
-                <a:latin typeface="Arial" pitchFamily="34" charset="0"/>
-                <a:ea typeface="Arial" pitchFamily="34" charset="-122"/>
-                <a:cs typeface="Arial" pitchFamily="34" charset="-120"/>
-              </a:rPr>
-              <a:t>Waarom?</a:t>
-            </a:r>
-            <a:endParaRPr lang="en-US" sz="1700" dirty="0"/>
-          </a:p>
-        </p:txBody>
-      </p:sp>
-      <p:sp>
-        <p:nvSpPr>
-          <p:cNvPr id="18" name="Text 16"/>
-          <p:cNvSpPr/>
-          <p:nvPr/>
-        </p:nvSpPr>
-        <p:spPr>
-          <a:xfrm>
-            <a:off x="658368" y="4005072"/>
-            <a:ext cx="7772400" cy="347472"/>
-          </a:xfrm>
-          <a:prstGeom prst="rect">
-            <a:avLst/>
-          </a:prstGeom>
-          <a:noFill/>
-          <a:ln/>
-        </p:spPr>
-        <p:txBody>
-          <a:bodyPr wrap="square" rtlCol="0" anchor="ctr"/>
-          <a:lstStyle/>
-          <a:p>
-            <a:pPr indent="0" marL="0">
-              <a:buNone/>
-            </a:pPr>
-            <a:r>
-              <a:rPr lang="en-US" sz="1400" dirty="0">
+                <a:latin typeface="Consolas" pitchFamily="34" charset="0"/>
+                <a:ea typeface="Consolas" pitchFamily="34" charset="-122"/>
+                <a:cs typeface="Consolas" pitchFamily="34" charset="-120"/>
+              </a:rPr>
+              <a:t>CS = ½ × 20 × 20
+</a:t>
+            </a:r>
+            <a:pPr algn="l" indent="0" marL="0">
+              <a:lnSpc>
+                <a:spcPct val="115000"/>
+              </a:lnSpc>
+              <a:buNone/>
+            </a:pPr>
+            <a:r>
+              <a:rPr lang="en-US" sz="1600" b="1" dirty="0">
                 <a:solidFill>
                   <a:srgbClr val="2D3748"/>
                 </a:solidFill>
-                <a:latin typeface="Arial" pitchFamily="34" charset="0"/>
-                <a:ea typeface="Arial" pitchFamily="34" charset="-122"/>
-                <a:cs typeface="Arial" pitchFamily="34" charset="-120"/>
-              </a:rPr>
-              <a:t>Hogere winst: ook consumenten met lagere betalingsbereidheid kopen</a:t>
+                <a:latin typeface="Consolas" pitchFamily="34" charset="0"/>
+                <a:ea typeface="Consolas" pitchFamily="34" charset="-122"/>
+                <a:cs typeface="Consolas" pitchFamily="34" charset="-120"/>
+              </a:rPr>
+              <a:t>CS = €200</a:t>
             </a:r>
             <a:endParaRPr lang="en-US" sz="1400" dirty="0"/>
           </a:p>
@@ -4890,460 +4738,36 @@
                 <a:ea typeface="Arial" pitchFamily="34" charset="-122"/>
                 <a:cs typeface="Arial" pitchFamily="34" charset="-120"/>
               </a:rPr>
-              <a:t>Waarom levert prijsdiscriminatie meer winst?</a:t>
+              <a:t>Winst en CS bij monopolie</a:t>
             </a:r>
             <a:endParaRPr lang="en-US" sz="2400" dirty="0"/>
           </a:p>
         </p:txBody>
       </p:sp>
-      <p:sp>
-        <p:nvSpPr>
-          <p:cNvPr id="3" name="Shape 1"/>
-          <p:cNvSpPr/>
-          <p:nvPr/>
-        </p:nvSpPr>
-        <p:spPr>
-          <a:xfrm>
-            <a:off x="1371600" y="1097280"/>
-            <a:ext cx="6400800" cy="594360"/>
-          </a:xfrm>
-          <a:prstGeom prst="rect">
-            <a:avLst>
-              <a:gd name="adj" fmla="val 7692"/>
-            </a:avLst>
-          </a:prstGeom>
-          <a:solidFill>
-            <a:srgbClr val="F9F6F1"/>
-          </a:solidFill>
-          <a:ln w="12700">
-            <a:solidFill>
-              <a:srgbClr val="1A5276"/>
-            </a:solidFill>
-            <a:prstDash val="solid"/>
-          </a:ln>
-          <a:effectLst>
-            <a:outerShdw sx="100000" sy="100000" kx="0" ky="0" algn="bl" rotWithShape="0" blurRad="76200" dist="25400" dir="8100000">
-              <a:srgbClr val="000000">
-                <a:alpha val="10000"/>
-              </a:srgbClr>
-            </a:outerShdw>
-          </a:effectLst>
-        </p:spPr>
-      </p:sp>
-      <p:sp>
-        <p:nvSpPr>
-          <p:cNvPr id="4" name="Text 2"/>
-          <p:cNvSpPr/>
-          <p:nvPr/>
-        </p:nvSpPr>
-        <p:spPr>
-          <a:xfrm>
-            <a:off x="1554480" y="1097280"/>
-            <a:ext cx="6035040" cy="594360"/>
-          </a:xfrm>
-          <a:prstGeom prst="rect">
-            <a:avLst/>
-          </a:prstGeom>
-          <a:noFill/>
-          <a:ln/>
-        </p:spPr>
-        <p:txBody>
-          <a:bodyPr wrap="square" rtlCol="0" anchor="ctr"/>
-          <a:lstStyle/>
-          <a:p>
-            <a:pPr indent="0" marL="0">
-              <a:buNone/>
-            </a:pPr>
-            <a:r>
-              <a:rPr lang="en-US" sz="1700" dirty="0">
-                <a:solidFill>
-                  <a:srgbClr val="2D3748"/>
-                </a:solidFill>
-                <a:latin typeface="Arial" pitchFamily="34" charset="0"/>
-                <a:ea typeface="Arial" pitchFamily="34" charset="-122"/>
-                <a:cs typeface="Arial" pitchFamily="34" charset="-120"/>
-              </a:rPr>
-              <a:t>Twee groepen onderscheiden</a:t>
-            </a:r>
-            <a:endParaRPr lang="en-US" sz="1700" dirty="0"/>
-          </a:p>
-        </p:txBody>
-      </p:sp>
-      <p:sp>
-        <p:nvSpPr>
-          <p:cNvPr id="5" name="Text 3"/>
-          <p:cNvSpPr/>
-          <p:nvPr/>
-        </p:nvSpPr>
-        <p:spPr>
-          <a:xfrm>
-            <a:off x="1371600" y="1691640"/>
-            <a:ext cx="6400800" cy="274320"/>
-          </a:xfrm>
-          <a:prstGeom prst="rect">
-            <a:avLst/>
-          </a:prstGeom>
-          <a:noFill/>
-          <a:ln/>
-        </p:spPr>
-        <p:txBody>
-          <a:bodyPr wrap="square" rtlCol="0" anchor="ctr"/>
-          <a:lstStyle/>
-          <a:p>
-            <a:pPr algn="ctr" indent="0" marL="0">
-              <a:buNone/>
-            </a:pPr>
-            <a:r>
-              <a:rPr lang="en-US" sz="1600" b="1" dirty="0">
-                <a:solidFill>
-                  <a:srgbClr val="1A5276"/>
-                </a:solidFill>
-                <a:latin typeface="Arial" pitchFamily="34" charset="0"/>
-                <a:ea typeface="Arial" pitchFamily="34" charset="-122"/>
-                <a:cs typeface="Arial" pitchFamily="34" charset="-120"/>
-              </a:rPr>
-              <a:t>↓</a:t>
-            </a:r>
-            <a:endParaRPr lang="en-US" sz="1600" dirty="0"/>
-          </a:p>
-        </p:txBody>
-      </p:sp>
-      <p:sp>
-        <p:nvSpPr>
-          <p:cNvPr id="6" name="Shape 4"/>
-          <p:cNvSpPr/>
-          <p:nvPr/>
-        </p:nvSpPr>
-        <p:spPr>
-          <a:xfrm>
-            <a:off x="1371600" y="1965960"/>
-            <a:ext cx="6400800" cy="594360"/>
-          </a:xfrm>
-          <a:prstGeom prst="rect">
-            <a:avLst>
-              <a:gd name="adj" fmla="val 7692"/>
-            </a:avLst>
-          </a:prstGeom>
-          <a:solidFill>
-            <a:srgbClr val="F9F6F1"/>
-          </a:solidFill>
-          <a:ln w="12700">
-            <a:solidFill>
-              <a:srgbClr val="1A5276"/>
-            </a:solidFill>
-            <a:prstDash val="solid"/>
-          </a:ln>
-          <a:effectLst>
-            <a:outerShdw sx="100000" sy="100000" kx="0" ky="0" algn="bl" rotWithShape="0" blurRad="76200" dist="25400" dir="8100000">
-              <a:srgbClr val="000000">
-                <a:alpha val="10000"/>
-              </a:srgbClr>
-            </a:outerShdw>
-          </a:effectLst>
-        </p:spPr>
-      </p:sp>
-      <p:sp>
-        <p:nvSpPr>
-          <p:cNvPr id="7" name="Text 5"/>
-          <p:cNvSpPr/>
-          <p:nvPr/>
-        </p:nvSpPr>
-        <p:spPr>
-          <a:xfrm>
-            <a:off x="1554480" y="1965960"/>
-            <a:ext cx="6035040" cy="594360"/>
-          </a:xfrm>
-          <a:prstGeom prst="rect">
-            <a:avLst/>
-          </a:prstGeom>
-          <a:noFill/>
-          <a:ln/>
-        </p:spPr>
-        <p:txBody>
-          <a:bodyPr wrap="square" rtlCol="0" anchor="ctr"/>
-          <a:lstStyle/>
-          <a:p>
-            <a:pPr indent="0" marL="0">
-              <a:buNone/>
-            </a:pPr>
-            <a:r>
-              <a:rPr lang="en-US" sz="1700" dirty="0">
-                <a:solidFill>
-                  <a:srgbClr val="2D3748"/>
-                </a:solidFill>
-                <a:latin typeface="Arial" pitchFamily="34" charset="0"/>
-                <a:ea typeface="Arial" pitchFamily="34" charset="-122"/>
-                <a:cs typeface="Arial" pitchFamily="34" charset="-120"/>
-              </a:rPr>
-              <a:t>Lagere prijs voor groep met lagere betalingsbereidheid</a:t>
-            </a:r>
-            <a:endParaRPr lang="en-US" sz="1700" dirty="0"/>
-          </a:p>
-        </p:txBody>
-      </p:sp>
-      <p:sp>
-        <p:nvSpPr>
-          <p:cNvPr id="8" name="Text 6"/>
-          <p:cNvSpPr/>
-          <p:nvPr/>
-        </p:nvSpPr>
-        <p:spPr>
-          <a:xfrm>
-            <a:off x="1371600" y="2560320"/>
-            <a:ext cx="6400800" cy="274320"/>
-          </a:xfrm>
-          <a:prstGeom prst="rect">
-            <a:avLst/>
-          </a:prstGeom>
-          <a:noFill/>
-          <a:ln/>
-        </p:spPr>
-        <p:txBody>
-          <a:bodyPr wrap="square" rtlCol="0" anchor="ctr"/>
-          <a:lstStyle/>
-          <a:p>
-            <a:pPr algn="ctr" indent="0" marL="0">
-              <a:buNone/>
-            </a:pPr>
-            <a:r>
-              <a:rPr lang="en-US" sz="1600" b="1" dirty="0">
-                <a:solidFill>
-                  <a:srgbClr val="1A5276"/>
-                </a:solidFill>
-                <a:latin typeface="Arial" pitchFamily="34" charset="0"/>
-                <a:ea typeface="Arial" pitchFamily="34" charset="-122"/>
-                <a:cs typeface="Arial" pitchFamily="34" charset="-120"/>
-              </a:rPr>
-              <a:t>↓</a:t>
-            </a:r>
-            <a:endParaRPr lang="en-US" sz="1600" dirty="0"/>
-          </a:p>
-        </p:txBody>
-      </p:sp>
-      <p:sp>
-        <p:nvSpPr>
-          <p:cNvPr id="9" name="Shape 7"/>
-          <p:cNvSpPr/>
-          <p:nvPr/>
-        </p:nvSpPr>
-        <p:spPr>
-          <a:xfrm>
-            <a:off x="1371600" y="2834640"/>
-            <a:ext cx="6400800" cy="594360"/>
-          </a:xfrm>
-          <a:prstGeom prst="rect">
-            <a:avLst>
-              <a:gd name="adj" fmla="val 7692"/>
-            </a:avLst>
-          </a:prstGeom>
-          <a:solidFill>
-            <a:srgbClr val="F9F6F1"/>
-          </a:solidFill>
-          <a:ln w="12700">
-            <a:solidFill>
-              <a:srgbClr val="1A5276"/>
-            </a:solidFill>
-            <a:prstDash val="solid"/>
-          </a:ln>
-          <a:effectLst>
-            <a:outerShdw sx="100000" sy="100000" kx="0" ky="0" algn="bl" rotWithShape="0" blurRad="76200" dist="25400" dir="8100000">
-              <a:srgbClr val="000000">
-                <a:alpha val="10000"/>
-              </a:srgbClr>
-            </a:outerShdw>
-          </a:effectLst>
-        </p:spPr>
-      </p:sp>
-      <p:sp>
-        <p:nvSpPr>
-          <p:cNvPr id="10" name="Text 8"/>
-          <p:cNvSpPr/>
-          <p:nvPr/>
-        </p:nvSpPr>
-        <p:spPr>
-          <a:xfrm>
-            <a:off x="1554480" y="2834640"/>
-            <a:ext cx="6035040" cy="594360"/>
-          </a:xfrm>
-          <a:prstGeom prst="rect">
-            <a:avLst/>
-          </a:prstGeom>
-          <a:noFill/>
-          <a:ln/>
-        </p:spPr>
-        <p:txBody>
-          <a:bodyPr wrap="square" rtlCol="0" anchor="ctr"/>
-          <a:lstStyle/>
-          <a:p>
-            <a:pPr indent="0" marL="0">
-              <a:buNone/>
-            </a:pPr>
-            <a:r>
-              <a:rPr lang="en-US" sz="1700" dirty="0">
-                <a:solidFill>
-                  <a:srgbClr val="2D3748"/>
-                </a:solidFill>
-                <a:latin typeface="Arial" pitchFamily="34" charset="0"/>
-                <a:ea typeface="Arial" pitchFamily="34" charset="-122"/>
-                <a:cs typeface="Arial" pitchFamily="34" charset="-120"/>
-              </a:rPr>
-              <a:t>Meer klanten (extra omzet)</a:t>
-            </a:r>
-            <a:endParaRPr lang="en-US" sz="1700" dirty="0"/>
-          </a:p>
-        </p:txBody>
-      </p:sp>
-      <p:sp>
-        <p:nvSpPr>
-          <p:cNvPr id="11" name="Text 9"/>
-          <p:cNvSpPr/>
-          <p:nvPr/>
-        </p:nvSpPr>
-        <p:spPr>
-          <a:xfrm>
-            <a:off x="1371600" y="3429000"/>
-            <a:ext cx="6400800" cy="274320"/>
-          </a:xfrm>
-          <a:prstGeom prst="rect">
-            <a:avLst/>
-          </a:prstGeom>
-          <a:noFill/>
-          <a:ln/>
-        </p:spPr>
-        <p:txBody>
-          <a:bodyPr wrap="square" rtlCol="0" anchor="ctr"/>
-          <a:lstStyle/>
-          <a:p>
-            <a:pPr algn="ctr" indent="0" marL="0">
-              <a:buNone/>
-            </a:pPr>
-            <a:r>
-              <a:rPr lang="en-US" sz="1600" b="1" dirty="0">
-                <a:solidFill>
-                  <a:srgbClr val="1A5276"/>
-                </a:solidFill>
-                <a:latin typeface="Arial" pitchFamily="34" charset="0"/>
-                <a:ea typeface="Arial" pitchFamily="34" charset="-122"/>
-                <a:cs typeface="Arial" pitchFamily="34" charset="-120"/>
-              </a:rPr>
-              <a:t>↓</a:t>
-            </a:r>
-            <a:endParaRPr lang="en-US" sz="1600" dirty="0"/>
-          </a:p>
-        </p:txBody>
-      </p:sp>
-      <p:sp>
-        <p:nvSpPr>
-          <p:cNvPr id="12" name="Shape 10"/>
-          <p:cNvSpPr/>
-          <p:nvPr/>
-        </p:nvSpPr>
-        <p:spPr>
-          <a:xfrm>
-            <a:off x="1371600" y="3703320"/>
-            <a:ext cx="6400800" cy="594360"/>
-          </a:xfrm>
-          <a:prstGeom prst="rect">
-            <a:avLst>
-              <a:gd name="adj" fmla="val 7692"/>
-            </a:avLst>
-          </a:prstGeom>
-          <a:solidFill>
-            <a:srgbClr val="1A5276"/>
-          </a:solidFill>
-          <a:ln w="12700">
-            <a:solidFill>
-              <a:srgbClr val="1A5276"/>
-            </a:solidFill>
-            <a:prstDash val="solid"/>
-          </a:ln>
-          <a:effectLst>
-            <a:outerShdw sx="100000" sy="100000" kx="0" ky="0" algn="bl" rotWithShape="0" blurRad="76200" dist="25400" dir="8100000">
-              <a:srgbClr val="000000">
-                <a:alpha val="10000"/>
-              </a:srgbClr>
-            </a:outerShdw>
-          </a:effectLst>
-        </p:spPr>
-      </p:sp>
-      <p:sp>
-        <p:nvSpPr>
-          <p:cNvPr id="13" name="Text 11"/>
-          <p:cNvSpPr/>
-          <p:nvPr/>
-        </p:nvSpPr>
-        <p:spPr>
-          <a:xfrm>
-            <a:off x="1554480" y="3703320"/>
-            <a:ext cx="6035040" cy="594360"/>
-          </a:xfrm>
-          <a:prstGeom prst="rect">
-            <a:avLst/>
-          </a:prstGeom>
-          <a:noFill/>
-          <a:ln/>
-        </p:spPr>
-        <p:txBody>
-          <a:bodyPr wrap="square" rtlCol="0" anchor="ctr"/>
-          <a:lstStyle/>
-          <a:p>
-            <a:pPr indent="0" marL="0">
-              <a:buNone/>
-            </a:pPr>
-            <a:r>
-              <a:rPr lang="en-US" sz="1700" b="1" dirty="0">
-                <a:solidFill>
-                  <a:srgbClr val="FFFFFF"/>
-                </a:solidFill>
-                <a:latin typeface="Arial" pitchFamily="34" charset="0"/>
-                <a:ea typeface="Arial" pitchFamily="34" charset="-122"/>
-                <a:cs typeface="Arial" pitchFamily="34" charset="-120"/>
-              </a:rPr>
-              <a:t>Winst stijgt (zolang p &gt; MK)</a:t>
-            </a:r>
-            <a:endParaRPr lang="en-US" sz="1700" dirty="0"/>
-          </a:p>
-        </p:txBody>
-      </p:sp>
-      <p:sp>
-        <p:nvSpPr>
-          <p:cNvPr id="14" name="Text 12"/>
-          <p:cNvSpPr/>
-          <p:nvPr/>
-        </p:nvSpPr>
-        <p:spPr>
-          <a:xfrm>
-            <a:off x="640080" y="4572000"/>
-            <a:ext cx="7863840" cy="365760"/>
-          </a:xfrm>
-          <a:prstGeom prst="rect">
-            <a:avLst/>
-          </a:prstGeom>
-          <a:noFill/>
-          <a:ln/>
-        </p:spPr>
-        <p:txBody>
-          <a:bodyPr wrap="square" rtlCol="0" anchor="ctr"/>
-          <a:lstStyle/>
-          <a:p>
-            <a:pPr indent="0" marL="0">
-              <a:buNone/>
-            </a:pPr>
-            <a:r>
-              <a:rPr lang="en-US" sz="1300" i="1" dirty="0">
-                <a:solidFill>
-                  <a:srgbClr val="718096"/>
-                </a:solidFill>
-                <a:latin typeface="Arial" pitchFamily="34" charset="0"/>
-                <a:ea typeface="Arial" pitchFamily="34" charset="-122"/>
-                <a:cs typeface="Arial" pitchFamily="34" charset="-120"/>
-              </a:rPr>
-              <a:t>Jongeren betalen minder, maar nog boven de MK → winstgevend</a:t>
-            </a:r>
-            <a:endParaRPr lang="en-US" sz="1300" dirty="0"/>
-          </a:p>
-        </p:txBody>
-      </p:sp>
+      <p:pic>
+        <p:nvPicPr>
+          <p:cNvPr id="3" name="Image 0" descr="preencoded.png">    </p:cNvPr>
+          <p:cNvPicPr>
+            <a:picLocks noChangeAspect="1"/>
+          </p:cNvPicPr>
+          <p:nvPr/>
+        </p:nvPicPr>
+        <p:blipFill>
+          <a:blip r:embed="rId1"/>
+          <a:stretch>
+            <a:fillRect/>
+          </a:stretch>
+        </p:blipFill>
+        <p:spPr>
+          <a:xfrm>
+            <a:off x="685800" y="822960"/>
+            <a:ext cx="7772400" cy="3886200"/>
+          </a:xfrm>
+          <a:prstGeom prst="rect">
+            <a:avLst/>
+          </a:prstGeom>
+        </p:spPr>
+      </p:pic>
     </p:spTree>
   </p:cSld>
   <p:clrMapOvr>
@@ -5377,8 +4801,8 @@
         </p:nvSpPr>
         <p:spPr>
           <a:xfrm>
-            <a:off x="640080" y="457200"/>
-            <a:ext cx="7863840" cy="640080"/>
+            <a:off x="457200" y="0"/>
+            <a:ext cx="8229600" cy="685800"/>
           </a:xfrm>
           <a:prstGeom prst="rect">
             <a:avLst/>
@@ -5394,7 +4818,7 @@
               <a:buNone/>
             </a:pPr>
             <a:r>
-              <a:rPr lang="en-US" sz="2800" b="1" dirty="0">
+              <a:rPr lang="en-US" sz="2400" b="1" dirty="0">
                 <a:solidFill>
                   <a:srgbClr val="FFFFFF"/>
                 </a:solidFill>
@@ -5402,22 +4826,71 @@
                 <a:ea typeface="Arial" pitchFamily="34" charset="-122"/>
                 <a:cs typeface="Arial" pitchFamily="34" charset="-120"/>
               </a:rPr>
-              <a:t>Samenvatting</a:t>
-            </a:r>
-            <a:endParaRPr lang="en-US" sz="2800" dirty="0"/>
-          </a:p>
-        </p:txBody>
-      </p:sp>
-      <p:sp>
-        <p:nvSpPr>
-          <p:cNvPr id="3" name="Text 1"/>
-          <p:cNvSpPr/>
-          <p:nvPr/>
-        </p:nvSpPr>
-        <p:spPr>
-          <a:xfrm>
-            <a:off x="640080" y="1051560"/>
-            <a:ext cx="7863840" cy="365760"/>
+              <a:t>Prijsdiscriminatie</a:t>
+            </a:r>
+            <a:endParaRPr lang="en-US" sz="2400" dirty="0"/>
+          </a:p>
+        </p:txBody>
+      </p:sp>
+      <p:sp>
+        <p:nvSpPr>
+          <p:cNvPr id="3" name="Shape 1"/>
+          <p:cNvSpPr/>
+          <p:nvPr/>
+        </p:nvSpPr>
+        <p:spPr>
+          <a:xfrm>
+            <a:off x="457200" y="1005840"/>
+            <a:ext cx="3931920" cy="1371600"/>
+          </a:xfrm>
+          <a:prstGeom prst="rect">
+            <a:avLst>
+              <a:gd name="adj" fmla="val 3333"/>
+            </a:avLst>
+          </a:prstGeom>
+          <a:solidFill>
+            <a:srgbClr val="F9F6F1"/>
+          </a:solidFill>
+          <a:ln/>
+          <a:effectLst>
+            <a:outerShdw sx="100000" sy="100000" kx="0" ky="0" algn="bl" rotWithShape="0" blurRad="76200" dist="25400" dir="8100000">
+              <a:srgbClr val="000000">
+                <a:alpha val="10000"/>
+              </a:srgbClr>
+            </a:outerShdw>
+          </a:effectLst>
+        </p:spPr>
+      </p:sp>
+      <p:sp>
+        <p:nvSpPr>
+          <p:cNvPr id="4" name="Shape 2"/>
+          <p:cNvSpPr/>
+          <p:nvPr/>
+        </p:nvSpPr>
+        <p:spPr>
+          <a:xfrm>
+            <a:off x="457200" y="1005840"/>
+            <a:ext cx="54864" cy="1371600"/>
+          </a:xfrm>
+          <a:prstGeom prst="rect">
+            <a:avLst/>
+          </a:prstGeom>
+          <a:solidFill>
+            <a:srgbClr val="7B2D8E"/>
+          </a:solidFill>
+          <a:ln/>
+        </p:spPr>
+      </p:sp>
+      <p:sp>
+        <p:nvSpPr>
+          <p:cNvPr id="5" name="Text 3"/>
+          <p:cNvSpPr/>
+          <p:nvPr/>
+        </p:nvSpPr>
+        <p:spPr>
+          <a:xfrm>
+            <a:off x="640080" y="1143000"/>
+            <a:ext cx="3611880" cy="365760"/>
           </a:xfrm>
           <a:prstGeom prst="rect">
             <a:avLst/>
@@ -5426,22 +4899,64 @@
           <a:ln/>
         </p:spPr>
         <p:txBody>
-          <a:bodyPr wrap="square" rtlCol="0" anchor="ctr"/>
+          <a:bodyPr wrap="square" rtlCol="0" anchor="t"/>
           <a:lstStyle/>
           <a:p>
             <a:pPr indent="0" marL="0">
               <a:buNone/>
             </a:pPr>
             <a:r>
-              <a:rPr lang="en-US" sz="1400" i="1" dirty="0">
-                <a:solidFill>
-                  <a:srgbClr val="718096"/>
-                </a:solidFill>
-                <a:latin typeface="Arial" pitchFamily="34" charset="0"/>
-                <a:ea typeface="Arial" pitchFamily="34" charset="-122"/>
-                <a:cs typeface="Arial" pitchFamily="34" charset="-120"/>
-              </a:rPr>
-              <a:t>Beheers je dit voordat je gaat oefenen?</a:t>
+              <a:rPr lang="en-US" sz="2000" b="1" dirty="0">
+                <a:solidFill>
+                  <a:srgbClr val="7B2D8E"/>
+                </a:solidFill>
+                <a:latin typeface="Arial" pitchFamily="34" charset="0"/>
+                <a:ea typeface="Arial" pitchFamily="34" charset="-122"/>
+                <a:cs typeface="Arial" pitchFamily="34" charset="-120"/>
+              </a:rPr>
+              <a:t>Wat is het?</a:t>
+            </a:r>
+            <a:endParaRPr lang="en-US" sz="2000" dirty="0"/>
+          </a:p>
+        </p:txBody>
+      </p:sp>
+      <p:sp>
+        <p:nvSpPr>
+          <p:cNvPr id="6" name="Text 4"/>
+          <p:cNvSpPr/>
+          <p:nvPr/>
+        </p:nvSpPr>
+        <p:spPr>
+          <a:xfrm>
+            <a:off x="640080" y="1554480"/>
+            <a:ext cx="3611880" cy="685800"/>
+          </a:xfrm>
+          <a:prstGeom prst="rect">
+            <a:avLst/>
+          </a:prstGeom>
+          <a:noFill/>
+          <a:ln/>
+        </p:spPr>
+        <p:txBody>
+          <a:bodyPr wrap="square" rtlCol="0" anchor="t"/>
+          <a:lstStyle/>
+          <a:p>
+            <a:pPr algn="l" indent="0" marL="0">
+              <a:lnSpc>
+                <a:spcPct val="115000"/>
+              </a:lnSpc>
+              <a:buNone/>
+            </a:pPr>
+            <a:r>
+              <a:rPr lang="en-US" sz="1400" dirty="0">
+                <a:solidFill>
+                  <a:srgbClr val="2D3748"/>
+                </a:solidFill>
+                <a:latin typeface="Arial" pitchFamily="34" charset="0"/>
+                <a:ea typeface="Arial" pitchFamily="34" charset="-122"/>
+                <a:cs typeface="Arial" pitchFamily="34" charset="-120"/>
+              </a:rPr>
+              <a:t>Verschillende prijzen vragen aan verschillende groepen voor hetzelfde product</a:t>
             </a:r>
             <a:endParaRPr lang="en-US" sz="1400" dirty="0"/>
           </a:p>
@@ -5449,14 +4964,63 @@
       </p:sp>
       <p:sp>
         <p:nvSpPr>
-          <p:cNvPr id="4" name="Text 2"/>
-          <p:cNvSpPr/>
-          <p:nvPr/>
-        </p:nvSpPr>
-        <p:spPr>
-          <a:xfrm>
-            <a:off x="640080" y="1554480"/>
-            <a:ext cx="7863840" cy="2926080"/>
+          <p:cNvPr id="7" name="Shape 5"/>
+          <p:cNvSpPr/>
+          <p:nvPr/>
+        </p:nvSpPr>
+        <p:spPr>
+          <a:xfrm>
+            <a:off x="4754880" y="1005840"/>
+            <a:ext cx="3931920" cy="1371600"/>
+          </a:xfrm>
+          <a:prstGeom prst="rect">
+            <a:avLst>
+              <a:gd name="adj" fmla="val 3333"/>
+            </a:avLst>
+          </a:prstGeom>
+          <a:solidFill>
+            <a:srgbClr val="F9F6F1"/>
+          </a:solidFill>
+          <a:ln/>
+          <a:effectLst>
+            <a:outerShdw sx="100000" sy="100000" kx="0" ky="0" algn="bl" rotWithShape="0" blurRad="76200" dist="25400" dir="8100000">
+              <a:srgbClr val="000000">
+                <a:alpha val="10000"/>
+              </a:srgbClr>
+            </a:outerShdw>
+          </a:effectLst>
+        </p:spPr>
+      </p:sp>
+      <p:sp>
+        <p:nvSpPr>
+          <p:cNvPr id="8" name="Shape 6"/>
+          <p:cNvSpPr/>
+          <p:nvPr/>
+        </p:nvSpPr>
+        <p:spPr>
+          <a:xfrm>
+            <a:off x="4754880" y="1005840"/>
+            <a:ext cx="54864" cy="1371600"/>
+          </a:xfrm>
+          <a:prstGeom prst="rect">
+            <a:avLst/>
+          </a:prstGeom>
+          <a:solidFill>
+            <a:srgbClr val="E67E22"/>
+          </a:solidFill>
+          <a:ln/>
+        </p:spPr>
+      </p:sp>
+      <p:sp>
+        <p:nvSpPr>
+          <p:cNvPr id="9" name="Text 7"/>
+          <p:cNvSpPr/>
+          <p:nvPr/>
+        </p:nvSpPr>
+        <p:spPr>
+          <a:xfrm>
+            <a:off x="4937760" y="1143000"/>
+            <a:ext cx="3611880" cy="365760"/>
           </a:xfrm>
           <a:prstGeom prst="rect">
             <a:avLst/>
@@ -5468,124 +5032,323 @@
           <a:bodyPr wrap="square" rtlCol="0" anchor="t"/>
           <a:lstStyle/>
           <a:p>
-            <a:pPr marL="342900" indent="-342900">
+            <a:pPr indent="0" marL="0">
+              <a:buNone/>
+            </a:pPr>
+            <a:r>
+              <a:rPr lang="en-US" sz="2000" b="1" dirty="0">
+                <a:solidFill>
+                  <a:srgbClr val="E67E22"/>
+                </a:solidFill>
+                <a:latin typeface="Arial" pitchFamily="34" charset="0"/>
+                <a:ea typeface="Arial" pitchFamily="34" charset="-122"/>
+                <a:cs typeface="Arial" pitchFamily="34" charset="-120"/>
+              </a:rPr>
+              <a:t>Waarom?</a:t>
+            </a:r>
+            <a:endParaRPr lang="en-US" sz="2000" dirty="0"/>
+          </a:p>
+        </p:txBody>
+      </p:sp>
+      <p:sp>
+        <p:nvSpPr>
+          <p:cNvPr id="10" name="Text 8"/>
+          <p:cNvSpPr/>
+          <p:nvPr/>
+        </p:nvSpPr>
+        <p:spPr>
+          <a:xfrm>
+            <a:off x="4937760" y="1554480"/>
+            <a:ext cx="3611880" cy="685800"/>
+          </a:xfrm>
+          <a:prstGeom prst="rect">
+            <a:avLst/>
+          </a:prstGeom>
+          <a:noFill/>
+          <a:ln/>
+        </p:spPr>
+        <p:txBody>
+          <a:bodyPr wrap="square" rtlCol="0" anchor="t"/>
+          <a:lstStyle/>
+          <a:p>
+            <a:pPr algn="l" indent="0" marL="0">
               <a:lnSpc>
-                <a:spcPct val="160000"/>
+                <a:spcPct val="115000"/>
               </a:lnSpc>
-              <a:spcAft>
-                <a:spcPts val="600"/>
-              </a:spcAft>
-              <a:buSzPct val="100000"/>
-              <a:buChar char="•"/>
-            </a:pPr>
-            <a:r>
-              <a:rPr lang="en-US" sz="1500" dirty="0">
-                <a:solidFill>
-                  <a:srgbClr val="FFFFFF"/>
-                </a:solidFill>
-                <a:latin typeface="Arial" pitchFamily="34" charset="0"/>
-                <a:ea typeface="Arial" pitchFamily="34" charset="-122"/>
-                <a:cs typeface="Arial" pitchFamily="34" charset="-120"/>
-              </a:rPr>
-              <a:t>De monopolist kiest zijn prijs op de vraaglijn (MO &lt; p)</a:t>
-            </a:r>
-            <a:endParaRPr lang="en-US" sz="1500" dirty="0"/>
-          </a:p>
-          <a:p>
-            <a:pPr marL="342900" indent="-342900">
+              <a:buNone/>
+            </a:pPr>
+            <a:r>
+              <a:rPr lang="en-US" sz="1400" dirty="0">
+                <a:solidFill>
+                  <a:srgbClr val="2D3748"/>
+                </a:solidFill>
+                <a:latin typeface="Arial" pitchFamily="34" charset="0"/>
+                <a:ea typeface="Arial" pitchFamily="34" charset="-122"/>
+                <a:cs typeface="Arial" pitchFamily="34" charset="-120"/>
+              </a:rPr>
+              <a:t>Hogere winst: ook consumenten met lagere betalingsbereidheid kopen</a:t>
+            </a:r>
+            <a:endParaRPr lang="en-US" sz="1400" dirty="0"/>
+          </a:p>
+        </p:txBody>
+      </p:sp>
+      <p:sp>
+        <p:nvSpPr>
+          <p:cNvPr id="11" name="Shape 9"/>
+          <p:cNvSpPr/>
+          <p:nvPr/>
+        </p:nvSpPr>
+        <p:spPr>
+          <a:xfrm>
+            <a:off x="457200" y="2651760"/>
+            <a:ext cx="3931920" cy="1188720"/>
+          </a:xfrm>
+          <a:prstGeom prst="rect">
+            <a:avLst>
+              <a:gd name="adj" fmla="val 3846"/>
+            </a:avLst>
+          </a:prstGeom>
+          <a:solidFill>
+            <a:srgbClr val="F9F6F1"/>
+          </a:solidFill>
+          <a:ln/>
+          <a:effectLst>
+            <a:outerShdw sx="100000" sy="100000" kx="0" ky="0" algn="bl" rotWithShape="0" blurRad="76200" dist="25400" dir="8100000">
+              <a:srgbClr val="000000">
+                <a:alpha val="10000"/>
+              </a:srgbClr>
+            </a:outerShdw>
+          </a:effectLst>
+        </p:spPr>
+      </p:sp>
+      <p:sp>
+        <p:nvSpPr>
+          <p:cNvPr id="12" name="Shape 10"/>
+          <p:cNvSpPr/>
+          <p:nvPr/>
+        </p:nvSpPr>
+        <p:spPr>
+          <a:xfrm>
+            <a:off x="457200" y="2651760"/>
+            <a:ext cx="54864" cy="1188720"/>
+          </a:xfrm>
+          <a:prstGeom prst="rect">
+            <a:avLst/>
+          </a:prstGeom>
+          <a:solidFill>
+            <a:srgbClr val="1A5276"/>
+          </a:solidFill>
+          <a:ln/>
+        </p:spPr>
+      </p:sp>
+      <p:sp>
+        <p:nvSpPr>
+          <p:cNvPr id="13" name="Text 11"/>
+          <p:cNvSpPr/>
+          <p:nvPr/>
+        </p:nvSpPr>
+        <p:spPr>
+          <a:xfrm>
+            <a:off x="640080" y="2788920"/>
+            <a:ext cx="3611880" cy="365760"/>
+          </a:xfrm>
+          <a:prstGeom prst="rect">
+            <a:avLst/>
+          </a:prstGeom>
+          <a:noFill/>
+          <a:ln/>
+        </p:spPr>
+        <p:txBody>
+          <a:bodyPr wrap="square" rtlCol="0" anchor="t"/>
+          <a:lstStyle/>
+          <a:p>
+            <a:pPr indent="0" marL="0">
+              <a:buNone/>
+            </a:pPr>
+            <a:r>
+              <a:rPr lang="en-US" sz="2000" b="1" dirty="0">
+                <a:solidFill>
+                  <a:srgbClr val="1A5276"/>
+                </a:solidFill>
+                <a:latin typeface="Arial" pitchFamily="34" charset="0"/>
+                <a:ea typeface="Arial" pitchFamily="34" charset="-122"/>
+                <a:cs typeface="Arial" pitchFamily="34" charset="-120"/>
+              </a:rPr>
+              <a:t>Voorwaarde 1</a:t>
+            </a:r>
+            <a:endParaRPr lang="en-US" sz="2000" dirty="0"/>
+          </a:p>
+        </p:txBody>
+      </p:sp>
+      <p:sp>
+        <p:nvSpPr>
+          <p:cNvPr id="14" name="Text 12"/>
+          <p:cNvSpPr/>
+          <p:nvPr/>
+        </p:nvSpPr>
+        <p:spPr>
+          <a:xfrm>
+            <a:off x="640080" y="3200400"/>
+            <a:ext cx="3611880" cy="502920"/>
+          </a:xfrm>
+          <a:prstGeom prst="rect">
+            <a:avLst/>
+          </a:prstGeom>
+          <a:noFill/>
+          <a:ln/>
+        </p:spPr>
+        <p:txBody>
+          <a:bodyPr wrap="square" rtlCol="0" anchor="t"/>
+          <a:lstStyle/>
+          <a:p>
+            <a:pPr algn="l" indent="0" marL="0">
               <a:lnSpc>
-                <a:spcPct val="160000"/>
+                <a:spcPct val="115000"/>
               </a:lnSpc>
-              <a:spcAft>
-                <a:spcPts val="600"/>
-              </a:spcAft>
-              <a:buSzPct val="100000"/>
-              <a:buChar char="•"/>
-            </a:pPr>
-            <a:r>
-              <a:rPr lang="en-US" sz="1500" dirty="0">
-                <a:solidFill>
-                  <a:srgbClr val="FFFFFF"/>
-                </a:solidFill>
-                <a:latin typeface="Arial" pitchFamily="34" charset="0"/>
-                <a:ea typeface="Arial" pitchFamily="34" charset="-122"/>
-                <a:cs typeface="Arial" pitchFamily="34" charset="-120"/>
-              </a:rPr>
-              <a:t>MO heeft dubbele helling van V, zelfde startpunt</a:t>
-            </a:r>
-            <a:endParaRPr lang="en-US" sz="1500" dirty="0"/>
-          </a:p>
-          <a:p>
-            <a:pPr marL="342900" indent="-342900">
+              <a:buNone/>
+            </a:pPr>
+            <a:r>
+              <a:rPr lang="en-US" sz="1300" dirty="0">
+                <a:solidFill>
+                  <a:srgbClr val="2D3748"/>
+                </a:solidFill>
+                <a:latin typeface="Arial" pitchFamily="34" charset="0"/>
+                <a:ea typeface="Arial" pitchFamily="34" charset="-122"/>
+                <a:cs typeface="Arial" pitchFamily="34" charset="-120"/>
+              </a:rPr>
+              <a:t>Marktsegmenten zijn te onderscheiden (bijv. jongeren vs. ouderen)</a:t>
+            </a:r>
+            <a:endParaRPr lang="en-US" sz="1400" dirty="0"/>
+          </a:p>
+        </p:txBody>
+      </p:sp>
+      <p:sp>
+        <p:nvSpPr>
+          <p:cNvPr id="15" name="Shape 13"/>
+          <p:cNvSpPr/>
+          <p:nvPr/>
+        </p:nvSpPr>
+        <p:spPr>
+          <a:xfrm>
+            <a:off x="4754880" y="2651760"/>
+            <a:ext cx="3931920" cy="1188720"/>
+          </a:xfrm>
+          <a:prstGeom prst="rect">
+            <a:avLst>
+              <a:gd name="adj" fmla="val 3846"/>
+            </a:avLst>
+          </a:prstGeom>
+          <a:solidFill>
+            <a:srgbClr val="F9F6F1"/>
+          </a:solidFill>
+          <a:ln/>
+          <a:effectLst>
+            <a:outerShdw sx="100000" sy="100000" kx="0" ky="0" algn="bl" rotWithShape="0" blurRad="76200" dist="25400" dir="8100000">
+              <a:srgbClr val="000000">
+                <a:alpha val="10000"/>
+              </a:srgbClr>
+            </a:outerShdw>
+          </a:effectLst>
+        </p:spPr>
+      </p:sp>
+      <p:sp>
+        <p:nvSpPr>
+          <p:cNvPr id="16" name="Shape 14"/>
+          <p:cNvSpPr/>
+          <p:nvPr/>
+        </p:nvSpPr>
+        <p:spPr>
+          <a:xfrm>
+            <a:off x="4754880" y="2651760"/>
+            <a:ext cx="54864" cy="1188720"/>
+          </a:xfrm>
+          <a:prstGeom prst="rect">
+            <a:avLst/>
+          </a:prstGeom>
+          <a:solidFill>
+            <a:srgbClr val="1A5276"/>
+          </a:solidFill>
+          <a:ln/>
+        </p:spPr>
+      </p:sp>
+      <p:sp>
+        <p:nvSpPr>
+          <p:cNvPr id="17" name="Text 15"/>
+          <p:cNvSpPr/>
+          <p:nvPr/>
+        </p:nvSpPr>
+        <p:spPr>
+          <a:xfrm>
+            <a:off x="4937760" y="2788920"/>
+            <a:ext cx="3611880" cy="365760"/>
+          </a:xfrm>
+          <a:prstGeom prst="rect">
+            <a:avLst/>
+          </a:prstGeom>
+          <a:noFill/>
+          <a:ln/>
+        </p:spPr>
+        <p:txBody>
+          <a:bodyPr wrap="square" rtlCol="0" anchor="t"/>
+          <a:lstStyle/>
+          <a:p>
+            <a:pPr indent="0" marL="0">
+              <a:buNone/>
+            </a:pPr>
+            <a:r>
+              <a:rPr lang="en-US" sz="2000" b="1" dirty="0">
+                <a:solidFill>
+                  <a:srgbClr val="1A5276"/>
+                </a:solidFill>
+                <a:latin typeface="Arial" pitchFamily="34" charset="0"/>
+                <a:ea typeface="Arial" pitchFamily="34" charset="-122"/>
+                <a:cs typeface="Arial" pitchFamily="34" charset="-120"/>
+              </a:rPr>
+              <a:t>Voorwaarde 2</a:t>
+            </a:r>
+            <a:endParaRPr lang="en-US" sz="2000" dirty="0"/>
+          </a:p>
+        </p:txBody>
+      </p:sp>
+      <p:sp>
+        <p:nvSpPr>
+          <p:cNvPr id="18" name="Text 16"/>
+          <p:cNvSpPr/>
+          <p:nvPr/>
+        </p:nvSpPr>
+        <p:spPr>
+          <a:xfrm>
+            <a:off x="4937760" y="3200400"/>
+            <a:ext cx="3611880" cy="502920"/>
+          </a:xfrm>
+          <a:prstGeom prst="rect">
+            <a:avLst/>
+          </a:prstGeom>
+          <a:noFill/>
+          <a:ln/>
+        </p:spPr>
+        <p:txBody>
+          <a:bodyPr wrap="square" rtlCol="0" anchor="t"/>
+          <a:lstStyle/>
+          <a:p>
+            <a:pPr algn="l" indent="0" marL="0">
               <a:lnSpc>
-                <a:spcPct val="160000"/>
+                <a:spcPct val="115000"/>
               </a:lnSpc>
-              <a:spcAft>
-                <a:spcPts val="600"/>
-              </a:spcAft>
-              <a:buSzPct val="100000"/>
-              <a:buChar char="•"/>
-            </a:pPr>
-            <a:r>
-              <a:rPr lang="en-US" sz="1500" dirty="0">
-                <a:solidFill>
-                  <a:srgbClr val="FFFFFF"/>
-                </a:solidFill>
-                <a:latin typeface="Arial" pitchFamily="34" charset="0"/>
-                <a:ea typeface="Arial" pitchFamily="34" charset="-122"/>
-                <a:cs typeface="Arial" pitchFamily="34" charset="-120"/>
-              </a:rPr>
-              <a:t>Winstmax: MO = MK → Q*, dan prijs aflezen op V</a:t>
-            </a:r>
-            <a:endParaRPr lang="en-US" sz="1500" dirty="0"/>
-          </a:p>
-          <a:p>
-            <a:pPr marL="342900" indent="-342900">
-              <a:lnSpc>
-                <a:spcPct val="160000"/>
-              </a:lnSpc>
-              <a:spcAft>
-                <a:spcPts val="600"/>
-              </a:spcAft>
-              <a:buSzPct val="100000"/>
-              <a:buChar char="•"/>
-            </a:pPr>
-            <a:r>
-              <a:rPr lang="en-US" sz="1500" dirty="0">
-                <a:solidFill>
-                  <a:srgbClr val="FFFFFF"/>
-                </a:solidFill>
-                <a:latin typeface="Arial" pitchFamily="34" charset="0"/>
-                <a:ea typeface="Arial" pitchFamily="34" charset="-122"/>
-                <a:cs typeface="Arial" pitchFamily="34" charset="-120"/>
-              </a:rPr>
-              <a:t>Winst = (p* − GTK) × Q*, CS = driehoek boven p*</a:t>
-            </a:r>
-            <a:endParaRPr lang="en-US" sz="1500" dirty="0"/>
-          </a:p>
-          <a:p>
-            <a:pPr marL="342900" indent="-342900">
-              <a:lnSpc>
-                <a:spcPct val="160000"/>
-              </a:lnSpc>
-              <a:spcAft>
-                <a:spcPts val="600"/>
-              </a:spcAft>
-              <a:buSzPct val="100000"/>
-              <a:buChar char="•"/>
-            </a:pPr>
-            <a:r>
-              <a:rPr lang="en-US" sz="1500" dirty="0">
-                <a:solidFill>
-                  <a:srgbClr val="FFFFFF"/>
-                </a:solidFill>
-                <a:latin typeface="Arial" pitchFamily="34" charset="0"/>
-                <a:ea typeface="Arial" pitchFamily="34" charset="-122"/>
-                <a:cs typeface="Arial" pitchFamily="34" charset="-120"/>
-              </a:rPr>
-              <a:t>Prijsdiscriminatie verhoogt de winst als p &gt; MK</a:t>
-            </a:r>
-            <a:endParaRPr lang="en-US" sz="1500" dirty="0"/>
+              <a:buNone/>
+            </a:pPr>
+            <a:r>
+              <a:rPr lang="en-US" sz="1300" dirty="0">
+                <a:solidFill>
+                  <a:srgbClr val="2D3748"/>
+                </a:solidFill>
+                <a:latin typeface="Arial" pitchFamily="34" charset="0"/>
+                <a:ea typeface="Arial" pitchFamily="34" charset="-122"/>
+                <a:cs typeface="Arial" pitchFamily="34" charset="-120"/>
+              </a:rPr>
+              <a:t>Doorverkoop is niet mogelijk (kaart op naam, digitaal product)</a:t>
+            </a:r>
+            <a:endParaRPr lang="en-US" sz="1400" dirty="0"/>
           </a:p>
         </p:txBody>
       </p:sp>

</xml_diff>